<commit_message>
Sederhanakan label kartu 'ditawari engineer' di halaman rekap
</commit_message>
<xml_diff>
--- a/dokumentasi/ppt/SIGAP-Presentasi-Kerja-Praktek.pptx
+++ b/dokumentasi/ppt/SIGAP-Presentasi-Kerja-Praktek.pptx
@@ -4,9 +4,6 @@
   <p:sldMasterIdLst>
     <p:sldMasterId id="2147483648" r:id="rId1"/>
   </p:sldMasterIdLst>
-  <p:notesMasterIdLst>
-    <p:notesMasterId r:id="rId24"/>
-  </p:notesMasterIdLst>
   <p:sldIdLst>
     <p:sldId id="256" r:id="rId2"/>
     <p:sldId id="257" r:id="rId3"/>
@@ -31,6 +28,9 @@
     <p:sldId id="276" r:id="rId22"/>
     <p:sldId id="277" r:id="rId23"/>
   </p:sldIdLst>
+  <p:notesMasterIdLst>
+    <p:notesMasterId r:id="rId24"/>
+  </p:notesMasterIdLst>
   <p:sldSz cx="12192000" cy="6858000"/>
   <p:notesSz cx="6858000" cy="12192000"/>
   <p:defaultTextStyle>
@@ -125,11 +125,6 @@
       </a:defRPr>
     </a:lvl9pPr>
   </p:defaultTextStyle>
-  <p:extLst>
-    <p:ext uri="{EFAFB233-063F-42B5-8137-9DF3F51BA10A}">
-      <p15:sldGuideLst xmlns:p15="http://schemas.microsoft.com/office/powerpoint/2012/main"/>
-    </p:ext>
-  </p:extLst>
 </p:presentation>
 </file>
 
@@ -155,10 +150,234 @@
           <a:chExt cx="0" cy="0"/>
         </a:xfrm>
       </p:grpSpPr>
+      <p:sp>
+        <p:nvSpPr>
+          <p:cNvPr id="2" name="Header Placeholder 1"/>
+          <p:cNvSpPr>
+            <a:spLocks noGrp="1"/>
+          </p:cNvSpPr>
+          <p:nvPr>
+            <p:ph type="hdr" sz="quarter"/>
+          </p:nvPr>
+        </p:nvSpPr>
+        <p:spPr>
+          <a:xfrm>
+            <a:off x="0" y="0"/>
+            <a:ext cx="2971800" cy="458788"/>
+          </a:xfrm>
+          <a:prstGeom prst="rect">
+            <a:avLst/>
+          </a:prstGeom>
+        </p:spPr>
+        <p:txBody>
+          <a:bodyPr vert="horz" lIns="91440" tIns="45720" rIns="91440" bIns="45720" rtlCol="0"/>
+          <a:lstStyle>
+            <a:lvl1pPr algn="l">
+              <a:defRPr sz="1200"/>
+            </a:lvl1pPr>
+          </a:lstStyle>
+          <a:p>
+            <a:endParaRPr lang="en-US"/>
+          </a:p>
+        </p:txBody>
+      </p:sp>
+      <p:sp>
+        <p:nvSpPr>
+          <p:cNvPr id="3" name="Date Placeholder 2"/>
+          <p:cNvSpPr>
+            <a:spLocks noGrp="1"/>
+          </p:cNvSpPr>
+          <p:nvPr>
+            <p:ph type="dt" idx="1"/>
+          </p:nvPr>
+        </p:nvSpPr>
+        <p:spPr>
+          <a:xfrm>
+            <a:off x="3884613" y="0"/>
+            <a:ext cx="2971800" cy="458788"/>
+          </a:xfrm>
+          <a:prstGeom prst="rect">
+            <a:avLst/>
+          </a:prstGeom>
+        </p:spPr>
+        <p:txBody>
+          <a:bodyPr vert="horz" lIns="91440" tIns="45720" rIns="91440" bIns="45720" rtlCol="0"/>
+          <a:lstStyle>
+            <a:lvl1pPr algn="r">
+              <a:defRPr sz="1200"/>
+            </a:lvl1pPr>
+          </a:lstStyle>
+          <a:p>
+            <a:fld id="{5282F153-3F37-0F45-9E97-73ACFA13230C}" type="datetimeFigureOut">
+              <a:rPr lang="en-US"/>
+              <a:t>7/23/19</a:t>
+            </a:fld>
+            <a:endParaRPr lang="en-US"/>
+          </a:p>
+        </p:txBody>
+      </p:sp>
+      <p:sp>
+        <p:nvSpPr>
+          <p:cNvPr id="4" name="Slide Image Placeholder 3"/>
+          <p:cNvSpPr>
+            <a:spLocks noGrp="1" noRot="1" noChangeAspect="1"/>
+          </p:cNvSpPr>
+          <p:nvPr>
+            <p:ph type="sldImg" idx="2"/>
+          </p:nvPr>
+        </p:nvSpPr>
+        <p:spPr>
+          <a:xfrm>
+            <a:off x="685800" y="1143000"/>
+            <a:ext cx="5486400" cy="3086100"/>
+          </a:xfrm>
+          <a:prstGeom prst="rect">
+            <a:avLst/>
+          </a:prstGeom>
+          <a:noFill/>
+          <a:ln w="12700">
+            <a:solidFill>
+              <a:prstClr val="black"/>
+            </a:solidFill>
+          </a:ln>
+        </p:spPr>
+        <p:txBody>
+          <a:bodyPr vert="horz" lIns="91440" tIns="45720" rIns="91440" bIns="45720" rtlCol="0" anchor="ctr"/>
+          <a:lstStyle/>
+          <a:p>
+            <a:endParaRPr lang="en-US"/>
+          </a:p>
+        </p:txBody>
+      </p:sp>
+      <p:sp>
+        <p:nvSpPr>
+          <p:cNvPr id="5" name="Notes Placeholder 4"/>
+          <p:cNvSpPr>
+            <a:spLocks noGrp="1"/>
+          </p:cNvSpPr>
+          <p:nvPr>
+            <p:ph type="body" sz="quarter" idx="3"/>
+          </p:nvPr>
+        </p:nvSpPr>
+        <p:spPr>
+          <a:xfrm>
+            <a:off x="685800" y="4400550"/>
+            <a:ext cx="5486400" cy="3600450"/>
+          </a:xfrm>
+          <a:prstGeom prst="rect">
+            <a:avLst/>
+          </a:prstGeom>
+        </p:spPr>
+        <p:txBody>
+          <a:bodyPr vert="horz" lIns="91440" tIns="45720" rIns="91440" bIns="45720" rtlCol="0"/>
+          <a:lstStyle/>
+          <a:p>
+            <a:pPr lvl="0"/>
+            <a:r>
+              <a:rPr lang="en-US"/>
+              <a:t>Click to edit Master text styles</a:t>
+            </a:r>
+          </a:p>
+          <a:p>
+            <a:pPr lvl="1"/>
+            <a:r>
+              <a:rPr lang="en-US"/>
+              <a:t>Second level</a:t>
+            </a:r>
+          </a:p>
+          <a:p>
+            <a:pPr lvl="2"/>
+            <a:r>
+              <a:rPr lang="en-US"/>
+              <a:t>Third level</a:t>
+            </a:r>
+          </a:p>
+          <a:p>
+            <a:pPr lvl="3"/>
+            <a:r>
+              <a:rPr lang="en-US"/>
+              <a:t>Fourth level</a:t>
+            </a:r>
+          </a:p>
+          <a:p>
+            <a:pPr lvl="4"/>
+            <a:r>
+              <a:rPr lang="en-US"/>
+              <a:t>Fifth level</a:t>
+            </a:r>
+          </a:p>
+        </p:txBody>
+      </p:sp>
+      <p:sp>
+        <p:nvSpPr>
+          <p:cNvPr id="6" name="Footer Placeholder 5"/>
+          <p:cNvSpPr>
+            <a:spLocks noGrp="1"/>
+          </p:cNvSpPr>
+          <p:nvPr>
+            <p:ph type="ftr" sz="quarter" idx="4"/>
+          </p:nvPr>
+        </p:nvSpPr>
+        <p:spPr>
+          <a:xfrm>
+            <a:off x="0" y="8685213"/>
+            <a:ext cx="2971800" cy="458787"/>
+          </a:xfrm>
+          <a:prstGeom prst="rect">
+            <a:avLst/>
+          </a:prstGeom>
+        </p:spPr>
+        <p:txBody>
+          <a:bodyPr vert="horz" lIns="91440" tIns="45720" rIns="91440" bIns="45720" rtlCol="0" anchor="b"/>
+          <a:lstStyle>
+            <a:lvl1pPr algn="l">
+              <a:defRPr sz="1200"/>
+            </a:lvl1pPr>
+          </a:lstStyle>
+          <a:p>
+            <a:endParaRPr lang="en-US"/>
+          </a:p>
+        </p:txBody>
+      </p:sp>
+      <p:sp>
+        <p:nvSpPr>
+          <p:cNvPr id="7" name="Slide Number Placeholder 6"/>
+          <p:cNvSpPr>
+            <a:spLocks noGrp="1"/>
+          </p:cNvSpPr>
+          <p:nvPr>
+            <p:ph type="sldNum" sz="quarter" idx="5"/>
+          </p:nvPr>
+        </p:nvSpPr>
+        <p:spPr>
+          <a:xfrm>
+            <a:off x="3884613" y="8685213"/>
+            <a:ext cx="2971800" cy="458787"/>
+          </a:xfrm>
+          <a:prstGeom prst="rect">
+            <a:avLst/>
+          </a:prstGeom>
+        </p:spPr>
+        <p:txBody>
+          <a:bodyPr vert="horz" lIns="91440" tIns="45720" rIns="91440" bIns="45720" rtlCol="0" anchor="b"/>
+          <a:lstStyle>
+            <a:lvl1pPr algn="r">
+              <a:defRPr sz="1200"/>
+            </a:lvl1pPr>
+          </a:lstStyle>
+          <a:p>
+            <a:fld id="{CE5E9CC1-C706-0F49-92D6-E571CC5EEA8F}" type="slidenum">
+              <a:rPr lang="en-US"/>
+              <a:t>‹#›</a:t>
+            </a:fld>
+            <a:endParaRPr lang="en-US"/>
+          </a:p>
+        </p:txBody>
+      </p:sp>
     </p:spTree>
     <p:extLst>
       <p:ext uri="{BB962C8B-B14F-4D97-AF65-F5344CB8AC3E}">
-        <p14:creationId xmlns:p14="http://schemas.microsoft.com/office/powerpoint/2010/main" val="908610433"/>
+        <p14:creationId xmlns:p14="http://schemas.microsoft.com/office/powerpoint/2010/main" val="1024086991"/>
       </p:ext>
     </p:extLst>
   </p:cSld>
@@ -306,6 +525,7 @@
               <a:rPr lang="en-US" dirty="0"/>
               <a:t>Selamat pagi. Kami dari Teknik Informatika UIR akan memaparkan hasil kerja praktek di Divisi IT Pertamina EP Field Lirik, berupa sistem bernama SIGAP.</a:t>
             </a:r>
+            <a:endParaRPr lang="en-US" dirty="0"/>
           </a:p>
         </p:txBody>
       </p:sp>
@@ -393,6 +613,7 @@
               <a:rPr lang="en-US" dirty="0"/>
               <a:t>Bagian ini menjelaskan mesin di balik SIGAP.</a:t>
             </a:r>
+            <a:endParaRPr lang="en-US" dirty="0"/>
           </a:p>
         </p:txBody>
       </p:sp>
@@ -480,6 +701,7 @@
               <a:rPr lang="en-US" dirty="0"/>
               <a:t>Sistem tidak memahami makna kalimat — ia membandingkan kata. Itu justru kelebihannya: jawabannya tidak pernah mengarang.</a:t>
             </a:r>
+            <a:endParaRPr lang="en-US" dirty="0"/>
           </a:p>
         </p:txBody>
       </p:sp>
@@ -567,6 +789,7 @@
               <a:rPr lang="en-US" dirty="0"/>
               <a:t>Admin dapat menguji kalimat keluhan langsung dari penyunting SOP dan melihat skornya, tanpa menunggu ada laporan masuk.</a:t>
             </a:r>
+            <a:endParaRPr lang="en-US" dirty="0"/>
           </a:p>
         </p:txBody>
       </p:sp>
@@ -654,6 +877,7 @@
               <a:rPr lang="en-US" dirty="0"/>
               <a:t>Bahasanya sengaja dibuat sederhana. Kami hindari istilah teknis, karena penggunanya pekerja lapangan, bukan orang IT.</a:t>
             </a:r>
+            <a:endParaRPr lang="en-US" dirty="0"/>
           </a:p>
         </p:txBody>
       </p:sp>
@@ -741,6 +965,7 @@
               <a:rPr lang="en-US" dirty="0"/>
               <a:t>Nomor tiket diberikan sejak sesi dimulai. Jadi walaupun pelapor berhenti di tengah, laporannya tetap tercatat untuk rekap.</a:t>
             </a:r>
+            <a:endParaRPr lang="en-US" dirty="0"/>
           </a:p>
         </p:txBody>
       </p:sp>
@@ -828,6 +1053,7 @@
               <a:rPr lang="en-US" dirty="0"/>
               <a:t>Formulir identitas sengaja diletakkan di akhir, bukan di awal. Supaya pekerja tidak malas melapor hanya karena harus mengisi data dulu.</a:t>
             </a:r>
+            <a:endParaRPr lang="en-US" dirty="0"/>
           </a:p>
         </p:txBody>
       </p:sp>
@@ -915,6 +1141,7 @@
               <a:rPr lang="en-US" dirty="0"/>
               <a:t>Admin melihat rekap untuk evaluasi, engineer melihat daftar tugas. Halaman tugas dibuat ringan karena dibuka dari ponsel di lapangan.</a:t>
             </a:r>
+            <a:endParaRPr lang="en-US" dirty="0"/>
           </a:p>
         </p:txBody>
       </p:sp>
@@ -1002,6 +1229,7 @@
               <a:rPr lang="en-US" dirty="0"/>
               <a:t>Bagian terakhir: apa yang dipakai membangunnya, dan apakah hasilnya benar-benar berjalan.</a:t>
             </a:r>
+            <a:endParaRPr lang="en-US" dirty="0"/>
           </a:p>
         </p:txBody>
       </p:sp>
@@ -1087,8 +1315,9 @@
           <a:p>
             <a:r>
               <a:rPr lang="en-US" dirty="0"/>
-              <a:t>Kami sengaja menahan diri menambah pustaka. Makin sedikit yang dipasang, makin sedikit yang perlu dirawat Fungsi IT nanti.</a:t>
-            </a:r>
+              <a:t>Kami sengaja tidak menambah banyak komponen. Makin sedikit yang dipasang, makin sedikit yang perlu dirawat Fungsi IT nanti.</a:t>
+            </a:r>
+            <a:endParaRPr lang="en-US" dirty="0"/>
           </a:p>
         </p:txBody>
       </p:sp>
@@ -1176,6 +1405,7 @@
               <a:rPr lang="en-US" dirty="0"/>
               <a:t>Selain menguji yang harus berhasil, kami juga menguji yang harus GAGAL — supaya sistem tidak asal menjawab.</a:t>
             </a:r>
+            <a:endParaRPr lang="en-US" dirty="0"/>
           </a:p>
         </p:txBody>
       </p:sp>
@@ -1263,6 +1493,7 @@
               <a:rPr lang="en-US" dirty="0"/>
               <a:t>Kami mulai dari keadaan sebelum ada sistem — supaya jelas apa yang sebenarnya ingin diperbaiki.</a:t>
             </a:r>
+            <a:endParaRPr lang="en-US" dirty="0"/>
           </a:p>
         </p:txBody>
       </p:sp>
@@ -1350,6 +1581,7 @@
               <a:rPr lang="en-US" dirty="0"/>
               <a:t>Sekarang kami tunjukkan langsung. Aplikasinya berjalan di laptop ini — bukan video, jadi Bapak/Ibu bisa meminta kami mencoba keluhan apa pun.</a:t>
             </a:r>
+            <a:endParaRPr lang="en-US" dirty="0"/>
           </a:p>
         </p:txBody>
       </p:sp>
@@ -1437,6 +1669,7 @@
               <a:rPr lang="en-US" dirty="0"/>
               <a:t>Kami sampaikan keterbatasannya terbuka, karena sistem ini akan diserahkan dan dirawat orang lain.</a:t>
             </a:r>
+            <a:endParaRPr lang="en-US" dirty="0"/>
           </a:p>
         </p:txBody>
       </p:sp>
@@ -1524,6 +1757,7 @@
               <a:rPr lang="en-US" dirty="0"/>
               <a:t>Terima kasih. Kami siap menerima pertanyaan dan masukan.</a:t>
             </a:r>
+            <a:endParaRPr lang="en-US" dirty="0"/>
           </a:p>
         </p:txBody>
       </p:sp>
@@ -1611,6 +1845,7 @@
               <a:rPr lang="en-US" dirty="0"/>
               <a:t>Masalahnya bukan engineernya kurang cakap, tapi tidak ada saluran yang tertata. Semua masuk lewat percakapan, dan percakapan tidak meninggalkan catatan.</a:t>
             </a:r>
+            <a:endParaRPr lang="en-US" dirty="0"/>
           </a:p>
         </p:txBody>
       </p:sp>
@@ -1698,6 +1933,7 @@
               <a:rPr lang="en-US" dirty="0"/>
               <a:t>Keempat masalah ini kami rumuskan dari pengamatan langsung dan wawancara dengan engineer di lapangan.</a:t>
             </a:r>
+            <a:endParaRPr lang="en-US" dirty="0"/>
           </a:p>
         </p:txBody>
       </p:sp>
@@ -1785,6 +2021,7 @@
               <a:rPr lang="en-US" dirty="0"/>
               <a:t>Tujuannya bukan menggantikan engineer, melainkan menyaring supaya yang sampai ke engineer benar-benar yang perlu.</a:t>
             </a:r>
+            <a:endParaRPr lang="en-US" dirty="0"/>
           </a:p>
         </p:txBody>
       </p:sp>
@@ -1872,6 +2109,7 @@
               <a:rPr lang="en-US" dirty="0"/>
               <a:t>Sekarang kami masuk ke sistemnya sendiri.</a:t>
             </a:r>
+            <a:endParaRPr lang="en-US" dirty="0"/>
           </a:p>
         </p:txBody>
       </p:sp>
@@ -1957,8 +2195,9 @@
           <a:p>
             <a:r>
               <a:rPr lang="en-US" dirty="0"/>
-              <a:t>SIGAP berbasis web, dibuka dari peramban. Pelapor tidak perlu akun — supaya tidak ada hambatan untuk melapor.</a:t>
-            </a:r>
+              <a:t>SIGAP berbasis web, dibuka dari browser. Pelapor tidak perlu akun — supaya tidak ada hambatan untuk melapor.</a:t>
+            </a:r>
+            <a:endParaRPr lang="en-US" dirty="0"/>
           </a:p>
         </p:txBody>
       </p:sp>
@@ -2046,6 +2285,7 @@
               <a:rPr lang="en-US" dirty="0"/>
               <a:t>Hanya printer dan Windows yang cukup umum untuk dipandu sendiri. Ini bukan keterbatasan teknis, melainkan keputusan engineer lapangan.</a:t>
             </a:r>
+            <a:endParaRPr lang="en-US" dirty="0"/>
           </a:p>
         </p:txBody>
       </p:sp>
@@ -2133,6 +2373,7 @@
               <a:rPr lang="en-US" dirty="0"/>
               <a:t>Sebelumnya alurnya lurus dan berhenti di kepala pihak IT. Sekarang pencocokan terjadi di dalam sistem, lalu alurnya bercabang.</a:t>
             </a:r>
+            <a:endParaRPr lang="en-US" dirty="0"/>
           </a:p>
         </p:txBody>
       </p:sp>
@@ -2205,11 +2446,6 @@
 <file path=ppt/slideMasters/slideMaster1.xml><?xml version="1.0" encoding="utf-8"?>
 <p:sldMaster xmlns:a="http://schemas.openxmlformats.org/drawingml/2006/main" xmlns:r="http://schemas.openxmlformats.org/officeDocument/2006/relationships" xmlns:p="http://schemas.openxmlformats.org/presentationml/2006/main">
   <p:cSld>
-    <p:bg>
-      <p:bgRef idx="1001">
-        <a:schemeClr val="bg1"/>
-      </p:bgRef>
-    </p:bg>
     <p:spTree>
       <p:nvGrpSpPr>
         <p:cNvPr id="1" name=""/>
@@ -2490,7 +2726,7 @@
     <p:bg>
       <p:bgPr>
         <a:blipFill dpi="0" rotWithShape="1">
-          <a:blip r:embed="rId3">
+          <a:blip r:embed="rId1">
             <a:lum/>
           </a:blip>
           <a:srcRect/>
@@ -2589,14 +2825,14 @@
       </p:sp>
       <p:pic>
         <p:nvPicPr>
-          <p:cNvPr id="5" name="Image 0" descr="D:\KILAT\KILAT-Ketersediaan-Informasi-Layanan-ICT-Terpadu-main\dokumentasi\ppt\ilustrasi\1-hero.jpg"/>
+          <p:cNvPr id="5" name="Image 0" descr="D:\KILAT\KILAT-Ketersediaan-Informasi-Layanan-ICT-Terpadu-main\dokumentasi\ppt\ilustrasi\1-hero.jpg">    </p:cNvPr>
           <p:cNvPicPr>
             <a:picLocks noChangeAspect="1"/>
           </p:cNvPicPr>
           <p:nvPr/>
         </p:nvPicPr>
         <p:blipFill>
-          <a:blip r:embed="rId4"/>
+          <a:blip r:embed="rId2"/>
           <a:stretch>
             <a:fillRect/>
           </a:stretch>
@@ -2632,13 +2868,6 @@
           </a:solidFill>
           <a:ln/>
         </p:spPr>
-        <p:txBody>
-          <a:bodyPr/>
-          <a:lstStyle/>
-          <a:p>
-            <a:endParaRPr lang="en-ID" dirty="0"/>
-          </a:p>
-        </p:txBody>
       </p:sp>
       <p:sp>
         <p:nvSpPr>
@@ -2661,11 +2890,11 @@
           <a:bodyPr wrap="square" lIns="0" tIns="0" rIns="0" bIns="0" rtlCol="0" anchor="ctr"/>
           <a:lstStyle/>
           <a:p>
-            <a:pPr marL="0" indent="0" algn="ctr">
-              <a:buNone/>
-            </a:pPr>
-            <a:r>
-              <a:rPr lang="en-US" sz="1050" b="1" kern="0" spc="140" dirty="0">
+            <a:pPr algn="ctr" indent="0" marL="0">
+              <a:buNone/>
+            </a:pPr>
+            <a:r>
+              <a:rPr lang="en-US" sz="1050" b="1" spc="140" kern="0" dirty="0">
                 <a:solidFill>
                   <a:srgbClr val="002B47"/>
                 </a:solidFill>
@@ -2700,7 +2929,7 @@
           <a:bodyPr wrap="square" lIns="0" tIns="0" rIns="0" bIns="0" rtlCol="0" anchor="t"/>
           <a:lstStyle/>
           <a:p>
-            <a:pPr marL="0" indent="0" algn="l">
+            <a:pPr algn="l" indent="0" marL="0">
               <a:buNone/>
             </a:pPr>
             <a:r>
@@ -2739,7 +2968,7 @@
           <a:bodyPr wrap="square" lIns="0" tIns="0" rIns="0" bIns="0" rtlCol="0" anchor="t"/>
           <a:lstStyle/>
           <a:p>
-            <a:pPr marL="0" indent="0" algn="l">
+            <a:pPr algn="l" indent="0" marL="0">
               <a:lnSpc>
                 <a:spcPts val="2700"/>
               </a:lnSpc>
@@ -2759,7 +2988,7 @@
             <a:endParaRPr lang="en-US" sz="2100" dirty="0"/>
           </a:p>
           <a:p>
-            <a:pPr marL="0" indent="0" algn="l">
+            <a:pPr algn="l" indent="0" marL="0">
               <a:lnSpc>
                 <a:spcPts val="2700"/>
               </a:lnSpc>
@@ -2821,7 +3050,7 @@
           <a:bodyPr wrap="square" lIns="0" tIns="0" rIns="0" bIns="0" rtlCol="0" anchor="t"/>
           <a:lstStyle/>
           <a:p>
-            <a:pPr marL="0" indent="0" algn="l">
+            <a:pPr algn="l" indent="0" marL="0">
               <a:lnSpc>
                 <a:spcPts val="1900"/>
               </a:lnSpc>
@@ -2841,7 +3070,7 @@
             <a:endParaRPr lang="en-US" sz="1350" dirty="0"/>
           </a:p>
           <a:p>
-            <a:pPr marL="0" indent="0" algn="l">
+            <a:pPr algn="l" indent="0" marL="0">
               <a:lnSpc>
                 <a:spcPts val="1900"/>
               </a:lnSpc>
@@ -2907,11 +3136,11 @@
           <a:bodyPr wrap="square" lIns="0" tIns="0" rIns="0" bIns="0" rtlCol="0" anchor="t"/>
           <a:lstStyle/>
           <a:p>
-            <a:pPr marL="0" indent="0" algn="l">
-              <a:buNone/>
-            </a:pPr>
-            <a:r>
-              <a:rPr lang="en-US" sz="950" b="1" kern="0" spc="150" dirty="0">
+            <a:pPr algn="l" indent="0" marL="0">
+              <a:buNone/>
+            </a:pPr>
+            <a:r>
+              <a:rPr lang="en-US" sz="950" b="1" spc="150" kern="0" dirty="0">
                 <a:solidFill>
                   <a:srgbClr val="ACC42A"/>
                 </a:solidFill>
@@ -2946,7 +3175,7 @@
           <a:bodyPr wrap="square" lIns="0" tIns="0" rIns="0" bIns="0" rtlCol="0" anchor="t"/>
           <a:lstStyle/>
           <a:p>
-            <a:pPr marL="0" indent="0" algn="l">
+            <a:pPr algn="l" indent="0" marL="0">
               <a:lnSpc>
                 <a:spcPts val="1700"/>
               </a:lnSpc>
@@ -2966,7 +3195,7 @@
             <a:endParaRPr lang="en-US" sz="1200" dirty="0"/>
           </a:p>
           <a:p>
-            <a:pPr marL="0" indent="0" algn="l">
+            <a:pPr algn="l" indent="0" marL="0">
               <a:lnSpc>
                 <a:spcPts val="1700"/>
               </a:lnSpc>
@@ -3008,7 +3237,7 @@
           <a:bodyPr wrap="square" lIns="0" tIns="0" rIns="0" bIns="0" rtlCol="0" anchor="t"/>
           <a:lstStyle/>
           <a:p>
-            <a:pPr marL="0" indent="0" algn="r">
+            <a:pPr algn="r" indent="0" marL="0">
               <a:lnSpc>
                 <a:spcPts val="1700"/>
               </a:lnSpc>
@@ -3028,7 +3257,7 @@
             <a:endParaRPr lang="en-US" sz="1200" dirty="0"/>
           </a:p>
           <a:p>
-            <a:pPr marL="0" indent="0" algn="r">
+            <a:pPr algn="r" indent="0" marL="0">
               <a:lnSpc>
                 <a:spcPts val="1700"/>
               </a:lnSpc>
@@ -3063,7 +3292,7 @@
     <p:bg>
       <p:bgPr>
         <a:blipFill dpi="0" rotWithShape="1">
-          <a:blip r:embed="rId3">
+          <a:blip r:embed="rId1">
             <a:lum/>
           </a:blip>
           <a:srcRect/>
@@ -3157,7 +3386,7 @@
           <a:bodyPr wrap="square" lIns="0" tIns="0" rIns="0" bIns="0" rtlCol="0" anchor="t"/>
           <a:lstStyle/>
           <a:p>
-            <a:pPr marL="0" indent="0" algn="l">
+            <a:pPr algn="l" indent="0" marL="0">
               <a:buNone/>
             </a:pPr>
             <a:r>
@@ -3216,7 +3445,7 @@
           <a:bodyPr wrap="square" lIns="0" tIns="0" rIns="0" bIns="0" rtlCol="0" anchor="t"/>
           <a:lstStyle/>
           <a:p>
-            <a:pPr marL="0" indent="0" algn="l">
+            <a:pPr algn="l" indent="0" marL="0">
               <a:buNone/>
             </a:pPr>
             <a:r>
@@ -3255,7 +3484,7 @@
           <a:bodyPr wrap="square" lIns="0" tIns="0" rIns="0" bIns="0" rtlCol="0" anchor="t"/>
           <a:lstStyle/>
           <a:p>
-            <a:pPr marL="0" indent="0" algn="l">
+            <a:pPr algn="l" indent="0" marL="0">
               <a:lnSpc>
                 <a:spcPts val="2300"/>
               </a:lnSpc>
@@ -3290,7 +3519,7 @@
     <p:bg>
       <p:bgPr>
         <a:blipFill dpi="0" rotWithShape="1">
-          <a:blip r:embed="rId3">
+          <a:blip r:embed="rId1">
             <a:lum/>
           </a:blip>
           <a:srcRect/>
@@ -3358,11 +3587,11 @@
           <a:bodyPr wrap="square" lIns="0" tIns="0" rIns="0" bIns="0" rtlCol="0" anchor="t"/>
           <a:lstStyle/>
           <a:p>
-            <a:pPr marL="0" indent="0" algn="l">
-              <a:buNone/>
-            </a:pPr>
-            <a:r>
-              <a:rPr lang="en-US" sz="1150" b="1" kern="0" spc="180" dirty="0">
+            <a:pPr algn="l" indent="0" marL="0">
+              <a:buNone/>
+            </a:pPr>
+            <a:r>
+              <a:rPr lang="en-US" sz="1150" b="1" spc="180" kern="0" dirty="0">
                 <a:solidFill>
                   <a:srgbClr val="005694"/>
                 </a:solidFill>
@@ -3397,7 +3626,7 @@
           <a:bodyPr wrap="square" lIns="0" tIns="0" rIns="0" bIns="0" rtlCol="0" anchor="t"/>
           <a:lstStyle/>
           <a:p>
-            <a:pPr marL="0" indent="0" algn="l">
+            <a:pPr algn="l" indent="0" marL="0">
               <a:buNone/>
             </a:pPr>
             <a:r>
@@ -3441,15 +3670,15 @@
       </p:sp>
       <p:pic>
         <p:nvPicPr>
-          <p:cNvPr id="6" name="Image 0" descr="D:\KILAT\KILAT-Ketersediaan-Informasi-Layanan-ICT-Terpadu-main\dokumentasi\ppt\ilustrasi\3-pencocokan.jpg"/>
+          <p:cNvPr id="6" name="Image 0" descr="D:\KILAT\KILAT-Ketersediaan-Informasi-Layanan-ICT-Terpadu-main\dokumentasi\ppt\ilustrasi\3-pencocokan.jpg">    </p:cNvPr>
           <p:cNvPicPr>
             <a:picLocks noChangeAspect="1"/>
           </p:cNvPicPr>
           <p:nvPr/>
         </p:nvPicPr>
         <p:blipFill>
-          <a:blip r:embed="rId4"/>
-          <a:srcRect/>
+          <a:blip r:embed="rId2"/>
+          <a:srcRect l="0" r="0" t="0" b="0"/>
           <a:stretch/>
         </p:blipFill>
         <p:spPr>
@@ -3529,7 +3758,7 @@
           <a:bodyPr wrap="square" lIns="0" tIns="0" rIns="0" bIns="0" rtlCol="0" anchor="ctr"/>
           <a:lstStyle/>
           <a:p>
-            <a:pPr marL="0" indent="0" algn="ctr">
+            <a:pPr algn="ctr" indent="0" marL="0">
               <a:buNone/>
             </a:pPr>
             <a:r>
@@ -3568,7 +3797,7 @@
           <a:bodyPr wrap="square" lIns="0" tIns="0" rIns="0" bIns="0" rtlCol="0" anchor="t"/>
           <a:lstStyle/>
           <a:p>
-            <a:pPr marL="0" indent="0" algn="l">
+            <a:pPr algn="l" indent="0" marL="0">
               <a:buNone/>
             </a:pPr>
             <a:r>
@@ -3607,7 +3836,7 @@
           <a:bodyPr wrap="square" lIns="0" tIns="0" rIns="0" bIns="0" rtlCol="0" anchor="t"/>
           <a:lstStyle/>
           <a:p>
-            <a:pPr marL="0" indent="0" algn="l">
+            <a:pPr algn="l" indent="0" marL="0">
               <a:lnSpc>
                 <a:spcPts val="1700"/>
               </a:lnSpc>
@@ -3695,7 +3924,7 @@
           <a:bodyPr wrap="square" lIns="0" tIns="0" rIns="0" bIns="0" rtlCol="0" anchor="ctr"/>
           <a:lstStyle/>
           <a:p>
-            <a:pPr marL="0" indent="0" algn="ctr">
+            <a:pPr algn="ctr" indent="0" marL="0">
               <a:buNone/>
             </a:pPr>
             <a:r>
@@ -3734,7 +3963,7 @@
           <a:bodyPr wrap="square" lIns="0" tIns="0" rIns="0" bIns="0" rtlCol="0" anchor="t"/>
           <a:lstStyle/>
           <a:p>
-            <a:pPr marL="0" indent="0" algn="l">
+            <a:pPr algn="l" indent="0" marL="0">
               <a:buNone/>
             </a:pPr>
             <a:r>
@@ -3773,7 +4002,7 @@
           <a:bodyPr wrap="square" lIns="0" tIns="0" rIns="0" bIns="0" rtlCol="0" anchor="t"/>
           <a:lstStyle/>
           <a:p>
-            <a:pPr marL="0" indent="0" algn="l">
+            <a:pPr algn="l" indent="0" marL="0">
               <a:lnSpc>
                 <a:spcPts val="1700"/>
               </a:lnSpc>
@@ -3861,7 +4090,7 @@
           <a:bodyPr wrap="square" lIns="0" tIns="0" rIns="0" bIns="0" rtlCol="0" anchor="ctr"/>
           <a:lstStyle/>
           <a:p>
-            <a:pPr marL="0" indent="0" algn="ctr">
+            <a:pPr algn="ctr" indent="0" marL="0">
               <a:buNone/>
             </a:pPr>
             <a:r>
@@ -3900,7 +4129,7 @@
           <a:bodyPr wrap="square" lIns="0" tIns="0" rIns="0" bIns="0" rtlCol="0" anchor="t"/>
           <a:lstStyle/>
           <a:p>
-            <a:pPr marL="0" indent="0" algn="l">
+            <a:pPr algn="l" indent="0" marL="0">
               <a:buNone/>
             </a:pPr>
             <a:r>
@@ -3939,7 +4168,7 @@
           <a:bodyPr wrap="square" lIns="0" tIns="0" rIns="0" bIns="0" rtlCol="0" anchor="t"/>
           <a:lstStyle/>
           <a:p>
-            <a:pPr marL="0" indent="0" algn="l">
+            <a:pPr algn="l" indent="0" marL="0">
               <a:lnSpc>
                 <a:spcPts val="1700"/>
               </a:lnSpc>
@@ -4027,7 +4256,7 @@
           <a:bodyPr wrap="square" lIns="0" tIns="0" rIns="0" bIns="0" rtlCol="0" anchor="ctr"/>
           <a:lstStyle/>
           <a:p>
-            <a:pPr marL="0" indent="0" algn="ctr">
+            <a:pPr algn="ctr" indent="0" marL="0">
               <a:buNone/>
             </a:pPr>
             <a:r>
@@ -4066,7 +4295,7 @@
           <a:bodyPr wrap="square" lIns="0" tIns="0" rIns="0" bIns="0" rtlCol="0" anchor="t"/>
           <a:lstStyle/>
           <a:p>
-            <a:pPr marL="0" indent="0" algn="l">
+            <a:pPr algn="l" indent="0" marL="0">
               <a:buNone/>
             </a:pPr>
             <a:r>
@@ -4105,7 +4334,7 @@
           <a:bodyPr wrap="square" lIns="0" tIns="0" rIns="0" bIns="0" rtlCol="0" anchor="t"/>
           <a:lstStyle/>
           <a:p>
-            <a:pPr marL="0" indent="0" algn="l">
+            <a:pPr algn="l" indent="0" marL="0">
               <a:lnSpc>
                 <a:spcPts val="1700"/>
               </a:lnSpc>
@@ -4169,7 +4398,7 @@
           <a:bodyPr wrap="square" lIns="0" tIns="0" rIns="0" bIns="0" rtlCol="0" anchor="t"/>
           <a:lstStyle/>
           <a:p>
-            <a:pPr marL="0" indent="0" algn="l">
+            <a:pPr algn="l" indent="0" marL="0">
               <a:buNone/>
             </a:pPr>
             <a:r>
@@ -4208,7 +4437,7 @@
           <a:bodyPr wrap="square" lIns="0" tIns="0" rIns="0" bIns="0" rtlCol="0" anchor="t"/>
           <a:lstStyle/>
           <a:p>
-            <a:pPr marL="0" indent="0" algn="l">
+            <a:pPr algn="l" indent="0" marL="0">
               <a:lnSpc>
                 <a:spcPts val="1600"/>
               </a:lnSpc>
@@ -4243,7 +4472,7 @@
     <p:bg>
       <p:bgPr>
         <a:blipFill dpi="0" rotWithShape="1">
-          <a:blip r:embed="rId3">
+          <a:blip r:embed="rId1">
             <a:lum/>
           </a:blip>
           <a:srcRect/>
@@ -4311,11 +4540,11 @@
           <a:bodyPr wrap="square" lIns="0" tIns="0" rIns="0" bIns="0" rtlCol="0" anchor="t"/>
           <a:lstStyle/>
           <a:p>
-            <a:pPr marL="0" indent="0" algn="l">
-              <a:buNone/>
-            </a:pPr>
-            <a:r>
-              <a:rPr lang="en-US" sz="1150" b="1" kern="0" spc="180" dirty="0">
+            <a:pPr algn="l" indent="0" marL="0">
+              <a:buNone/>
+            </a:pPr>
+            <a:r>
+              <a:rPr lang="en-US" sz="1150" b="1" spc="180" kern="0" dirty="0">
                 <a:solidFill>
                   <a:srgbClr val="005694"/>
                 </a:solidFill>
@@ -4350,7 +4579,7 @@
           <a:bodyPr wrap="square" lIns="0" tIns="0" rIns="0" bIns="0" rtlCol="0" anchor="t"/>
           <a:lstStyle/>
           <a:p>
-            <a:pPr marL="0" indent="0" algn="l">
+            <a:pPr algn="l" indent="0" marL="0">
               <a:buNone/>
             </a:pPr>
             <a:r>
@@ -4394,15 +4623,15 @@
       </p:sp>
       <p:pic>
         <p:nvPicPr>
-          <p:cNvPr id="6" name="Image 0" descr="D:\KILAT\KILAT-Ketersediaan-Informasi-Layanan-ICT-Terpadu-main\dokumentasi\tangkapan-layar\laporan\02-pencocokan-kata-kunci.png"/>
+          <p:cNvPr id="6" name="Image 0" descr="D:\KILAT\KILAT-Ketersediaan-Informasi-Layanan-ICT-Terpadu-main\dokumentasi\tangkapan-layar\laporan\02-pencocokan-kata-kunci.png">    </p:cNvPr>
           <p:cNvPicPr>
             <a:picLocks noChangeAspect="1"/>
           </p:cNvPicPr>
           <p:nvPr/>
         </p:nvPicPr>
         <p:blipFill>
-          <a:blip r:embed="rId4"/>
-          <a:srcRect/>
+          <a:blip r:embed="rId2"/>
+          <a:srcRect l="0" r="0" t="0" b="0"/>
           <a:stretch/>
         </p:blipFill>
         <p:spPr>
@@ -4458,11 +4687,11 @@
           <a:bodyPr wrap="square" lIns="0" tIns="0" rIns="0" bIns="0" rtlCol="0" anchor="t"/>
           <a:lstStyle/>
           <a:p>
-            <a:pPr marL="0" indent="0" algn="l">
-              <a:buNone/>
-            </a:pPr>
-            <a:r>
-              <a:rPr lang="en-US" sz="1050" b="1" kern="0" spc="140" dirty="0">
+            <a:pPr algn="l" indent="0" marL="0">
+              <a:buNone/>
+            </a:pPr>
+            <a:r>
+              <a:rPr lang="en-US" sz="1050" b="1" spc="140" kern="0" dirty="0">
                 <a:solidFill>
                   <a:srgbClr val="3F4E10"/>
                 </a:solidFill>
@@ -4497,7 +4726,7 @@
           <a:bodyPr wrap="square" lIns="0" tIns="0" rIns="0" bIns="0" rtlCol="0" anchor="t"/>
           <a:lstStyle/>
           <a:p>
-            <a:pPr marL="0" indent="0" algn="l">
+            <a:pPr algn="l" indent="0" marL="0">
               <a:buNone/>
             </a:pPr>
             <a:r>
@@ -4536,11 +4765,11 @@
           <a:bodyPr wrap="square" lIns="0" tIns="0" rIns="0" bIns="0" rtlCol="0" anchor="t"/>
           <a:lstStyle/>
           <a:p>
-            <a:pPr marL="0" indent="0" algn="l">
-              <a:buNone/>
-            </a:pPr>
-            <a:r>
-              <a:rPr lang="en-US" sz="1050" b="1" kern="0" spc="140" dirty="0">
+            <a:pPr algn="l" indent="0" marL="0">
+              <a:buNone/>
+            </a:pPr>
+            <a:r>
+              <a:rPr lang="en-US" sz="1050" b="1" spc="140" kern="0" dirty="0">
                 <a:solidFill>
                   <a:srgbClr val="3F4E10"/>
                 </a:solidFill>
@@ -4575,7 +4804,7 @@
           <a:bodyPr wrap="square" lIns="0" tIns="0" rIns="0" bIns="0" rtlCol="0" anchor="t"/>
           <a:lstStyle/>
           <a:p>
-            <a:pPr marL="0" indent="0" algn="l">
+            <a:pPr algn="l" indent="0" marL="0">
               <a:buNone/>
             </a:pPr>
             <a:r>
@@ -4636,7 +4865,7 @@
           <a:bodyPr wrap="square" lIns="0" tIns="0" rIns="0" bIns="0" rtlCol="0" anchor="t"/>
           <a:lstStyle/>
           <a:p>
-            <a:pPr marL="0" indent="0" algn="ctr">
+            <a:pPr algn="ctr" indent="0" marL="0">
               <a:buNone/>
             </a:pPr>
             <a:r>
@@ -4675,7 +4904,7 @@
           <a:bodyPr wrap="square" lIns="0" tIns="0" rIns="0" bIns="0" rtlCol="0" anchor="t"/>
           <a:lstStyle/>
           <a:p>
-            <a:pPr marL="0" indent="0" algn="ctr">
+            <a:pPr algn="ctr" indent="0" marL="0">
               <a:buNone/>
             </a:pPr>
             <a:r>
@@ -4738,7 +4967,7 @@
           <a:bodyPr wrap="square" lIns="0" tIns="0" rIns="0" bIns="0" rtlCol="0" anchor="t"/>
           <a:lstStyle/>
           <a:p>
-            <a:pPr marL="0" indent="0" algn="ctr">
+            <a:pPr algn="ctr" indent="0" marL="0">
               <a:buNone/>
             </a:pPr>
             <a:r>
@@ -4777,7 +5006,7 @@
           <a:bodyPr wrap="square" lIns="0" tIns="0" rIns="0" bIns="0" rtlCol="0" anchor="t"/>
           <a:lstStyle/>
           <a:p>
-            <a:pPr marL="0" indent="0" algn="ctr">
+            <a:pPr algn="ctr" indent="0" marL="0">
               <a:buNone/>
             </a:pPr>
             <a:r>
@@ -4816,7 +5045,7 @@
           <a:bodyPr wrap="square" lIns="0" tIns="0" rIns="0" bIns="0" rtlCol="0" anchor="t"/>
           <a:lstStyle/>
           <a:p>
-            <a:pPr marL="0" indent="0" algn="l">
+            <a:pPr algn="l" indent="0" marL="0">
               <a:lnSpc>
                 <a:spcPts val="1600"/>
               </a:lnSpc>
@@ -4851,7 +5080,7 @@
     <p:bg>
       <p:bgPr>
         <a:blipFill dpi="0" rotWithShape="1">
-          <a:blip r:embed="rId3">
+          <a:blip r:embed="rId1">
             <a:lum/>
           </a:blip>
           <a:srcRect/>
@@ -4919,11 +5148,11 @@
           <a:bodyPr wrap="square" lIns="0" tIns="0" rIns="0" bIns="0" rtlCol="0" anchor="t"/>
           <a:lstStyle/>
           <a:p>
-            <a:pPr marL="0" indent="0" algn="l">
-              <a:buNone/>
-            </a:pPr>
-            <a:r>
-              <a:rPr lang="en-US" sz="1150" b="1" kern="0" spc="180" dirty="0">
+            <a:pPr algn="l" indent="0" marL="0">
+              <a:buNone/>
+            </a:pPr>
+            <a:r>
+              <a:rPr lang="en-US" sz="1150" b="1" spc="180" kern="0" dirty="0">
                 <a:solidFill>
                   <a:srgbClr val="5C6A0D"/>
                 </a:solidFill>
@@ -4958,7 +5187,7 @@
           <a:bodyPr wrap="square" lIns="0" tIns="0" rIns="0" bIns="0" rtlCol="0" anchor="t"/>
           <a:lstStyle/>
           <a:p>
-            <a:pPr marL="0" indent="0" algn="l">
+            <a:pPr algn="l" indent="0" marL="0">
               <a:buNone/>
             </a:pPr>
             <a:r>
@@ -5002,15 +5231,15 @@
       </p:sp>
       <p:pic>
         <p:nvPicPr>
-          <p:cNvPr id="6" name="Image 0" descr="D:\KILAT\KILAT-Ketersediaan-Informasi-Layanan-ICT-Terpadu-main\dokumentasi\tangkapan-layar\laporan\03-panduan-printer.png"/>
+          <p:cNvPr id="6" name="Image 0" descr="D:\KILAT\KILAT-Ketersediaan-Informasi-Layanan-ICT-Terpadu-main\dokumentasi\tangkapan-layar\laporan\03-panduan-printer.png">    </p:cNvPr>
           <p:cNvPicPr>
             <a:picLocks noChangeAspect="1"/>
           </p:cNvPicPr>
           <p:nvPr/>
         </p:nvPicPr>
         <p:blipFill>
-          <a:blip r:embed="rId4"/>
-          <a:srcRect/>
+          <a:blip r:embed="rId2"/>
+          <a:srcRect l="0" r="0" t="0" b="0"/>
           <a:stretch/>
         </p:blipFill>
         <p:spPr>
@@ -5066,7 +5295,7 @@
           <a:bodyPr wrap="square" lIns="0" tIns="0" rIns="0" bIns="0" rtlCol="0" anchor="t"/>
           <a:lstStyle/>
           <a:p>
-            <a:pPr marL="0" indent="0" algn="l">
+            <a:pPr algn="l" indent="0" marL="0">
               <a:lnSpc>
                 <a:spcPts val="1800"/>
               </a:lnSpc>
@@ -5154,7 +5383,7 @@
           <a:bodyPr wrap="square" lIns="0" tIns="0" rIns="0" bIns="0" rtlCol="0" anchor="t"/>
           <a:lstStyle/>
           <a:p>
-            <a:pPr marL="0" indent="0" algn="l">
+            <a:pPr algn="l" indent="0" marL="0">
               <a:buNone/>
             </a:pPr>
             <a:r>
@@ -5193,7 +5422,7 @@
           <a:bodyPr wrap="square" lIns="0" tIns="0" rIns="0" bIns="0" rtlCol="0" anchor="t"/>
           <a:lstStyle/>
           <a:p>
-            <a:pPr marL="0" indent="0" algn="l">
+            <a:pPr algn="l" indent="0" marL="0">
               <a:lnSpc>
                 <a:spcPts val="1600"/>
               </a:lnSpc>
@@ -5281,7 +5510,7 @@
           <a:bodyPr wrap="square" lIns="0" tIns="0" rIns="0" bIns="0" rtlCol="0" anchor="t"/>
           <a:lstStyle/>
           <a:p>
-            <a:pPr marL="0" indent="0" algn="l">
+            <a:pPr algn="l" indent="0" marL="0">
               <a:buNone/>
             </a:pPr>
             <a:r>
@@ -5320,7 +5549,7 @@
           <a:bodyPr wrap="square" lIns="0" tIns="0" rIns="0" bIns="0" rtlCol="0" anchor="t"/>
           <a:lstStyle/>
           <a:p>
-            <a:pPr marL="0" indent="0" algn="l">
+            <a:pPr algn="l" indent="0" marL="0">
               <a:lnSpc>
                 <a:spcPts val="1600"/>
               </a:lnSpc>
@@ -5408,7 +5637,7 @@
           <a:bodyPr wrap="square" lIns="0" tIns="0" rIns="0" bIns="0" rtlCol="0" anchor="t"/>
           <a:lstStyle/>
           <a:p>
-            <a:pPr marL="0" indent="0" algn="l">
+            <a:pPr algn="l" indent="0" marL="0">
               <a:buNone/>
             </a:pPr>
             <a:r>
@@ -5447,7 +5676,7 @@
           <a:bodyPr wrap="square" lIns="0" tIns="0" rIns="0" bIns="0" rtlCol="0" anchor="t"/>
           <a:lstStyle/>
           <a:p>
-            <a:pPr marL="0" indent="0" algn="l">
+            <a:pPr algn="l" indent="0" marL="0">
               <a:lnSpc>
                 <a:spcPts val="1600"/>
               </a:lnSpc>
@@ -5511,7 +5740,7 @@
           <a:bodyPr wrap="square" lIns="0" tIns="0" rIns="0" bIns="0" rtlCol="0" anchor="ctr"/>
           <a:lstStyle/>
           <a:p>
-            <a:pPr marL="0" indent="0" algn="l">
+            <a:pPr algn="l" indent="0" marL="0">
               <a:buNone/>
             </a:pPr>
             <a:r>
@@ -5543,7 +5772,7 @@
     <p:bg>
       <p:bgPr>
         <a:blipFill dpi="0" rotWithShape="1">
-          <a:blip r:embed="rId3">
+          <a:blip r:embed="rId1">
             <a:lum/>
           </a:blip>
           <a:srcRect/>
@@ -5611,11 +5840,11 @@
           <a:bodyPr wrap="square" lIns="0" tIns="0" rIns="0" bIns="0" rtlCol="0" anchor="t"/>
           <a:lstStyle/>
           <a:p>
-            <a:pPr marL="0" indent="0" algn="l">
-              <a:buNone/>
-            </a:pPr>
-            <a:r>
-              <a:rPr lang="en-US" sz="1150" b="1" kern="0" spc="180" dirty="0">
+            <a:pPr algn="l" indent="0" marL="0">
+              <a:buNone/>
+            </a:pPr>
+            <a:r>
+              <a:rPr lang="en-US" sz="1150" b="1" spc="180" kern="0" dirty="0">
                 <a:solidFill>
                   <a:srgbClr val="005694"/>
                 </a:solidFill>
@@ -5650,7 +5879,7 @@
           <a:bodyPr wrap="square" lIns="0" tIns="0" rIns="0" bIns="0" rtlCol="0" anchor="t"/>
           <a:lstStyle/>
           <a:p>
-            <a:pPr marL="0" indent="0" algn="l">
+            <a:pPr algn="l" indent="0" marL="0">
               <a:buNone/>
             </a:pPr>
             <a:r>
@@ -5694,15 +5923,15 @@
       </p:sp>
       <p:pic>
         <p:nvPicPr>
-          <p:cNvPr id="6" name="Image 0" descr="D:\KILAT\KILAT-Ketersediaan-Informasi-Layanan-ICT-Terpadu-main\dokumentasi\tangkapan-layar\laporan\05b-nomor-tiket-cek-status.png"/>
+          <p:cNvPr id="6" name="Image 0" descr="D:\KILAT\KILAT-Ketersediaan-Informasi-Layanan-ICT-Terpadu-main\dokumentasi\tangkapan-layar\laporan\05b-nomor-tiket-cek-status.png">    </p:cNvPr>
           <p:cNvPicPr>
             <a:picLocks noChangeAspect="1"/>
           </p:cNvPicPr>
           <p:nvPr/>
         </p:nvPicPr>
         <p:blipFill>
-          <a:blip r:embed="rId4"/>
-          <a:srcRect/>
+          <a:blip r:embed="rId2"/>
+          <a:srcRect l="0" r="0" t="0" b="0"/>
           <a:stretch/>
         </p:blipFill>
         <p:spPr>
@@ -5758,7 +5987,7 @@
           <a:bodyPr wrap="square" lIns="0" tIns="0" rIns="0" bIns="0" rtlCol="0" anchor="t"/>
           <a:lstStyle/>
           <a:p>
-            <a:pPr marL="0" indent="0" algn="ctr">
+            <a:pPr algn="ctr" indent="0" marL="0">
               <a:buNone/>
             </a:pPr>
             <a:r>
@@ -5797,7 +6026,7 @@
           <a:bodyPr wrap="square" lIns="0" tIns="0" rIns="0" bIns="0" rtlCol="0" anchor="t"/>
           <a:lstStyle/>
           <a:p>
-            <a:pPr marL="0" indent="0" algn="ctr">
+            <a:pPr algn="ctr" indent="0" marL="0">
               <a:buNone/>
             </a:pPr>
             <a:r>
@@ -5880,7 +6109,7 @@
           <a:bodyPr wrap="square" lIns="0" tIns="0" rIns="0" bIns="0" rtlCol="0" anchor="t"/>
           <a:lstStyle/>
           <a:p>
-            <a:pPr marL="0" indent="0" algn="l">
+            <a:pPr algn="l" indent="0" marL="0">
               <a:buNone/>
             </a:pPr>
             <a:r>
@@ -5919,7 +6148,7 @@
           <a:bodyPr wrap="square" lIns="0" tIns="0" rIns="0" bIns="0" rtlCol="0" anchor="t"/>
           <a:lstStyle/>
           <a:p>
-            <a:pPr marL="0" indent="0" algn="l">
+            <a:pPr algn="l" indent="0" marL="0">
               <a:lnSpc>
                 <a:spcPts val="1600"/>
               </a:lnSpc>
@@ -6005,7 +6234,7 @@
           <a:bodyPr wrap="square" lIns="0" tIns="0" rIns="0" bIns="0" rtlCol="0" anchor="t"/>
           <a:lstStyle/>
           <a:p>
-            <a:pPr marL="0" indent="0" algn="l">
+            <a:pPr algn="l" indent="0" marL="0">
               <a:buNone/>
             </a:pPr>
             <a:r>
@@ -6044,7 +6273,7 @@
           <a:bodyPr wrap="square" lIns="0" tIns="0" rIns="0" bIns="0" rtlCol="0" anchor="t"/>
           <a:lstStyle/>
           <a:p>
-            <a:pPr marL="0" indent="0" algn="l">
+            <a:pPr algn="l" indent="0" marL="0">
               <a:lnSpc>
                 <a:spcPts val="1600"/>
               </a:lnSpc>
@@ -6130,7 +6359,7 @@
           <a:bodyPr wrap="square" lIns="0" tIns="0" rIns="0" bIns="0" rtlCol="0" anchor="t"/>
           <a:lstStyle/>
           <a:p>
-            <a:pPr marL="0" indent="0" algn="l">
+            <a:pPr algn="l" indent="0" marL="0">
               <a:buNone/>
             </a:pPr>
             <a:r>
@@ -6169,7 +6398,7 @@
           <a:bodyPr wrap="square" lIns="0" tIns="0" rIns="0" bIns="0" rtlCol="0" anchor="t"/>
           <a:lstStyle/>
           <a:p>
-            <a:pPr marL="0" indent="0" algn="l">
+            <a:pPr algn="l" indent="0" marL="0">
               <a:lnSpc>
                 <a:spcPts val="1600"/>
               </a:lnSpc>
@@ -6204,7 +6433,7 @@
     <p:bg>
       <p:bgPr>
         <a:blipFill dpi="0" rotWithShape="1">
-          <a:blip r:embed="rId3">
+          <a:blip r:embed="rId1">
             <a:lum/>
           </a:blip>
           <a:srcRect/>
@@ -6272,11 +6501,11 @@
           <a:bodyPr wrap="square" lIns="0" tIns="0" rIns="0" bIns="0" rtlCol="0" anchor="t"/>
           <a:lstStyle/>
           <a:p>
-            <a:pPr marL="0" indent="0" algn="l">
-              <a:buNone/>
-            </a:pPr>
-            <a:r>
-              <a:rPr lang="en-US" sz="1150" b="1" kern="0" spc="180" dirty="0">
+            <a:pPr algn="l" indent="0" marL="0">
+              <a:buNone/>
+            </a:pPr>
+            <a:r>
+              <a:rPr lang="en-US" sz="1150" b="1" spc="180" kern="0" dirty="0">
                 <a:solidFill>
                   <a:srgbClr val="005694"/>
                 </a:solidFill>
@@ -6311,7 +6540,7 @@
           <a:bodyPr wrap="square" lIns="0" tIns="0" rIns="0" bIns="0" rtlCol="0" anchor="t"/>
           <a:lstStyle/>
           <a:p>
-            <a:pPr marL="0" indent="0" algn="l">
+            <a:pPr algn="l" indent="0" marL="0">
               <a:buNone/>
             </a:pPr>
             <a:r>
@@ -6355,14 +6584,14 @@
       </p:sp>
       <p:pic>
         <p:nvPicPr>
-          <p:cNvPr id="6" name="Image 0" descr="D:\KILAT\KILAT-Ketersediaan-Informasi-Layanan-ICT-Terpadu-main\dokumentasi\ppt\ilustrasi\4-engineer.jpg"/>
+          <p:cNvPr id="6" name="Image 0" descr="D:\KILAT\KILAT-Ketersediaan-Informasi-Layanan-ICT-Terpadu-main\dokumentasi\ppt\ilustrasi\4-engineer.jpg">    </p:cNvPr>
           <p:cNvPicPr>
             <a:picLocks noChangeAspect="1"/>
           </p:cNvPicPr>
           <p:nvPr/>
         </p:nvPicPr>
         <p:blipFill>
-          <a:blip r:embed="rId4"/>
+          <a:blip r:embed="rId2"/>
           <a:stretch>
             <a:fillRect/>
           </a:stretch>
@@ -6444,7 +6673,7 @@
           <a:bodyPr wrap="square" lIns="0" tIns="0" rIns="0" bIns="0" rtlCol="0" anchor="t"/>
           <a:lstStyle/>
           <a:p>
-            <a:pPr marL="0" indent="0" algn="l">
+            <a:pPr algn="l" indent="0" marL="0">
               <a:buNone/>
             </a:pPr>
             <a:r>
@@ -6505,7 +6734,7 @@
           <a:bodyPr wrap="square" lIns="0" tIns="0" rIns="0" bIns="0" rtlCol="0" anchor="t"/>
           <a:lstStyle/>
           <a:p>
-            <a:pPr marL="0" indent="0" algn="l">
+            <a:pPr algn="l" indent="0" marL="0">
               <a:buNone/>
             </a:pPr>
             <a:r>
@@ -6566,7 +6795,7 @@
           <a:bodyPr wrap="square" lIns="0" tIns="0" rIns="0" bIns="0" rtlCol="0" anchor="t"/>
           <a:lstStyle/>
           <a:p>
-            <a:pPr marL="0" indent="0" algn="l">
+            <a:pPr algn="l" indent="0" marL="0">
               <a:buNone/>
             </a:pPr>
             <a:r>
@@ -6610,15 +6839,15 @@
       </p:sp>
       <p:pic>
         <p:nvPicPr>
-          <p:cNvPr id="15" name="Image 1" descr="D:\KILAT\KILAT-Ketersediaan-Informasi-Layanan-ICT-Terpadu-main\dokumentasi\tangkapan-layar\laporan\06b-eskalasi-serah-terima-whatsapp.png"/>
+          <p:cNvPr id="15" name="Image 1" descr="D:\KILAT\KILAT-Ketersediaan-Informasi-Layanan-ICT-Terpadu-main\dokumentasi\tangkapan-layar\laporan\06b-eskalasi-serah-terima-whatsapp.png">    </p:cNvPr>
           <p:cNvPicPr>
             <a:picLocks noChangeAspect="1"/>
           </p:cNvPicPr>
           <p:nvPr/>
         </p:nvPicPr>
         <p:blipFill>
-          <a:blip r:embed="rId5"/>
-          <a:srcRect/>
+          <a:blip r:embed="rId3"/>
+          <a:srcRect l="0" r="0" t="0" b="0"/>
           <a:stretch/>
         </p:blipFill>
         <p:spPr>
@@ -6674,7 +6903,7 @@
           <a:bodyPr wrap="square" lIns="0" tIns="0" rIns="0" bIns="0" rtlCol="0" anchor="t"/>
           <a:lstStyle/>
           <a:p>
-            <a:pPr marL="0" indent="0" algn="l">
+            <a:pPr algn="l" indent="0" marL="0">
               <a:lnSpc>
                 <a:spcPts val="1700"/>
               </a:lnSpc>
@@ -6709,7 +6938,7 @@
     <p:bg>
       <p:bgPr>
         <a:blipFill dpi="0" rotWithShape="1">
-          <a:blip r:embed="rId3">
+          <a:blip r:embed="rId1">
             <a:lum/>
           </a:blip>
           <a:srcRect/>
@@ -6777,11 +7006,11 @@
           <a:bodyPr wrap="square" lIns="0" tIns="0" rIns="0" bIns="0" rtlCol="0" anchor="t"/>
           <a:lstStyle/>
           <a:p>
-            <a:pPr marL="0" indent="0" algn="l">
-              <a:buNone/>
-            </a:pPr>
-            <a:r>
-              <a:rPr lang="en-US" sz="1150" b="1" kern="0" spc="180" dirty="0">
+            <a:pPr algn="l" indent="0" marL="0">
+              <a:buNone/>
+            </a:pPr>
+            <a:r>
+              <a:rPr lang="en-US" sz="1150" b="1" spc="180" kern="0" dirty="0">
                 <a:solidFill>
                   <a:srgbClr val="005694"/>
                 </a:solidFill>
@@ -6816,7 +7045,7 @@
           <a:bodyPr wrap="square" lIns="0" tIns="0" rIns="0" bIns="0" rtlCol="0" anchor="t"/>
           <a:lstStyle/>
           <a:p>
-            <a:pPr marL="0" indent="0" algn="l">
+            <a:pPr algn="l" indent="0" marL="0">
               <a:buNone/>
             </a:pPr>
             <a:r>
@@ -6877,11 +7106,11 @@
           <a:bodyPr wrap="square" lIns="0" tIns="0" rIns="0" bIns="0" rtlCol="0" anchor="t"/>
           <a:lstStyle/>
           <a:p>
-            <a:pPr marL="0" indent="0" algn="l">
-              <a:buNone/>
-            </a:pPr>
-            <a:r>
-              <a:rPr lang="en-US" sz="1150" b="1" kern="0" spc="150" dirty="0">
+            <a:pPr algn="l" indent="0" marL="0">
+              <a:buNone/>
+            </a:pPr>
+            <a:r>
+              <a:rPr lang="en-US" sz="1150" b="1" spc="150" kern="0" dirty="0">
                 <a:solidFill>
                   <a:srgbClr val="006CB8"/>
                 </a:solidFill>
@@ -6921,15 +7150,15 @@
       </p:sp>
       <p:pic>
         <p:nvPicPr>
-          <p:cNvPr id="8" name="Image 0" descr="D:\KILAT\KILAT-Ketersediaan-Informasi-Layanan-ICT-Terpadu-main\dokumentasi\tangkapan-layar\13-rekap-layar-pertama.png"/>
+          <p:cNvPr id="8" name="Image 0" descr="D:\KILAT\KILAT-Ketersediaan-Informasi-Layanan-ICT-Terpadu-main\dokumentasi\tangkapan-layar\13-rekap-layar-pertama.png">    </p:cNvPr>
           <p:cNvPicPr>
             <a:picLocks noChangeAspect="1"/>
           </p:cNvPicPr>
           <p:nvPr/>
         </p:nvPicPr>
         <p:blipFill>
-          <a:blip r:embed="rId4"/>
-          <a:srcRect/>
+          <a:blip r:embed="rId2"/>
+          <a:srcRect l="0" r="0" t="0" b="0"/>
           <a:stretch/>
         </p:blipFill>
         <p:spPr>
@@ -6985,7 +7214,7 @@
           <a:bodyPr wrap="square" lIns="0" tIns="0" rIns="0" bIns="0" rtlCol="0" anchor="t"/>
           <a:lstStyle/>
           <a:p>
-            <a:pPr marL="0" indent="0" algn="l">
+            <a:pPr algn="l" indent="0" marL="0">
               <a:lnSpc>
                 <a:spcPts val="1600"/>
               </a:lnSpc>
@@ -7049,11 +7278,11 @@
           <a:bodyPr wrap="square" lIns="0" tIns="0" rIns="0" bIns="0" rtlCol="0" anchor="t"/>
           <a:lstStyle/>
           <a:p>
-            <a:pPr marL="0" indent="0" algn="l">
-              <a:buNone/>
-            </a:pPr>
-            <a:r>
-              <a:rPr lang="en-US" sz="1150" b="1" kern="0" spc="150" dirty="0">
+            <a:pPr algn="l" indent="0" marL="0">
+              <a:buNone/>
+            </a:pPr>
+            <a:r>
+              <a:rPr lang="en-US" sz="1150" b="1" spc="150" kern="0" dirty="0">
                 <a:solidFill>
                   <a:srgbClr val="8AA019"/>
                 </a:solidFill>
@@ -7093,15 +7322,15 @@
       </p:sp>
       <p:pic>
         <p:nvPicPr>
-          <p:cNvPr id="14" name="Image 1" descr="D:\KILAT\KILAT-Ketersediaan-Informasi-Layanan-ICT-Terpadu-main\dokumentasi\tangkapan-layar\laporan\06-eskalasi-antrian-engineer.png"/>
+          <p:cNvPr id="14" name="Image 1" descr="D:\KILAT\KILAT-Ketersediaan-Informasi-Layanan-ICT-Terpadu-main\dokumentasi\tangkapan-layar\laporan\06-eskalasi-antrian-engineer.png">    </p:cNvPr>
           <p:cNvPicPr>
             <a:picLocks noChangeAspect="1"/>
           </p:cNvPicPr>
           <p:nvPr/>
         </p:nvPicPr>
         <p:blipFill>
-          <a:blip r:embed="rId5"/>
-          <a:srcRect/>
+          <a:blip r:embed="rId3"/>
+          <a:srcRect l="0" r="0" t="0" b="0"/>
           <a:stretch/>
         </p:blipFill>
         <p:spPr>
@@ -7157,7 +7386,7 @@
           <a:bodyPr wrap="square" lIns="0" tIns="0" rIns="0" bIns="0" rtlCol="0" anchor="t"/>
           <a:lstStyle/>
           <a:p>
-            <a:pPr marL="0" indent="0" algn="l">
+            <a:pPr algn="l" indent="0" marL="0">
               <a:lnSpc>
                 <a:spcPts val="1600"/>
               </a:lnSpc>
@@ -7192,7 +7421,7 @@
     <p:bg>
       <p:bgPr>
         <a:blipFill dpi="0" rotWithShape="1">
-          <a:blip r:embed="rId3">
+          <a:blip r:embed="rId1">
             <a:lum/>
           </a:blip>
           <a:srcRect/>
@@ -7286,7 +7515,7 @@
           <a:bodyPr wrap="square" lIns="0" tIns="0" rIns="0" bIns="0" rtlCol="0" anchor="t"/>
           <a:lstStyle/>
           <a:p>
-            <a:pPr marL="0" indent="0" algn="l">
+            <a:pPr algn="l" indent="0" marL="0">
               <a:buNone/>
             </a:pPr>
             <a:r>
@@ -7345,7 +7574,7 @@
           <a:bodyPr wrap="square" lIns="0" tIns="0" rIns="0" bIns="0" rtlCol="0" anchor="t"/>
           <a:lstStyle/>
           <a:p>
-            <a:pPr marL="0" indent="0" algn="l">
+            <a:pPr algn="l" indent="0" marL="0">
               <a:buNone/>
             </a:pPr>
             <a:r>
@@ -7384,7 +7613,7 @@
           <a:bodyPr wrap="square" lIns="0" tIns="0" rIns="0" bIns="0" rtlCol="0" anchor="t"/>
           <a:lstStyle/>
           <a:p>
-            <a:pPr marL="0" indent="0" algn="l">
+            <a:pPr algn="l" indent="0" marL="0">
               <a:lnSpc>
                 <a:spcPts val="2300"/>
               </a:lnSpc>
@@ -7419,7 +7648,7 @@
     <p:bg>
       <p:bgPr>
         <a:blipFill dpi="0" rotWithShape="1">
-          <a:blip r:embed="rId3">
+          <a:blip r:embed="rId1">
             <a:lum/>
           </a:blip>
           <a:srcRect/>
@@ -7487,11 +7716,11 @@
           <a:bodyPr wrap="square" lIns="0" tIns="0" rIns="0" bIns="0" rtlCol="0" anchor="t"/>
           <a:lstStyle/>
           <a:p>
-            <a:pPr marL="0" indent="0" algn="l">
-              <a:buNone/>
-            </a:pPr>
-            <a:r>
-              <a:rPr lang="en-US" sz="1150" b="1" kern="0" spc="180" dirty="0">
+            <a:pPr algn="l" indent="0" marL="0">
+              <a:buNone/>
+            </a:pPr>
+            <a:r>
+              <a:rPr lang="en-US" sz="1150" b="1" spc="180" kern="0" dirty="0">
                 <a:solidFill>
                   <a:srgbClr val="005694"/>
                 </a:solidFill>
@@ -7526,7 +7755,7 @@
           <a:bodyPr wrap="square" lIns="0" tIns="0" rIns="0" bIns="0" rtlCol="0" anchor="t"/>
           <a:lstStyle/>
           <a:p>
-            <a:pPr marL="0" indent="0" algn="l">
+            <a:pPr algn="l" indent="0" marL="0">
               <a:buNone/>
             </a:pPr>
             <a:r>
@@ -7587,7 +7816,7 @@
           <a:bodyPr wrap="square" lIns="0" tIns="0" rIns="0" bIns="0" rtlCol="0" anchor="t"/>
           <a:lstStyle/>
           <a:p>
-            <a:pPr marL="0" indent="0" algn="l">
+            <a:pPr algn="l" indent="0" marL="0">
               <a:buNone/>
             </a:pPr>
             <a:r>
@@ -7626,11 +7855,11 @@
           <a:bodyPr wrap="square" lIns="0" tIns="0" rIns="0" bIns="0" rtlCol="0" anchor="t"/>
           <a:lstStyle/>
           <a:p>
-            <a:pPr marL="0" indent="0" algn="l">
-              <a:buNone/>
-            </a:pPr>
-            <a:r>
-              <a:rPr lang="en-US" sz="950" b="1" kern="0" spc="130" dirty="0">
+            <a:pPr algn="l" indent="0" marL="0">
+              <a:buNone/>
+            </a:pPr>
+            <a:r>
+              <a:rPr lang="en-US" sz="950" b="1" spc="130" kern="0" dirty="0">
                 <a:solidFill>
                   <a:srgbClr val="BBD4E8"/>
                 </a:solidFill>
@@ -7638,7 +7867,7 @@
                 <a:ea typeface="Calibri" pitchFamily="34" charset="-122"/>
                 <a:cs typeface="Calibri" pitchFamily="34" charset="-120"/>
               </a:rPr>
-              <a:t>PELADEN APLIKASI</a:t>
+              <a:t>SERVER</a:t>
             </a:r>
             <a:endParaRPr lang="en-US" sz="950" dirty="0"/>
           </a:p>
@@ -7665,7 +7894,7 @@
           <a:bodyPr wrap="square" lIns="0" tIns="0" rIns="0" bIns="0" rtlCol="0" anchor="t"/>
           <a:lstStyle/>
           <a:p>
-            <a:pPr marL="0" indent="0" algn="l">
+            <a:pPr algn="l" indent="0" marL="0">
               <a:lnSpc>
                 <a:spcPts val="1700"/>
               </a:lnSpc>
@@ -7680,7 +7909,7 @@
                 <a:ea typeface="Calibri" pitchFamily="34" charset="-122"/>
                 <a:cs typeface="Calibri" pitchFamily="34" charset="-120"/>
               </a:rPr>
-              <a:t>Hanya empat pustaka luar — sisanya modul bawaan.</a:t>
+              <a:t>Hanya empat komponen tambahan. Sisanya sudah bawaan.</a:t>
             </a:r>
             <a:endParaRPr lang="en-US" sz="1250" dirty="0"/>
           </a:p>
@@ -7729,7 +7958,7 @@
           <a:bodyPr wrap="square" lIns="0" tIns="0" rIns="0" bIns="0" rtlCol="0" anchor="t"/>
           <a:lstStyle/>
           <a:p>
-            <a:pPr marL="0" indent="0" algn="l">
+            <a:pPr algn="l" indent="0" marL="0">
               <a:buNone/>
             </a:pPr>
             <a:r>
@@ -7768,11 +7997,11 @@
           <a:bodyPr wrap="square" lIns="0" tIns="0" rIns="0" bIns="0" rtlCol="0" anchor="t"/>
           <a:lstStyle/>
           <a:p>
-            <a:pPr marL="0" indent="0" algn="l">
-              <a:buNone/>
-            </a:pPr>
-            <a:r>
-              <a:rPr lang="en-US" sz="950" b="1" kern="0" spc="130" dirty="0">
+            <a:pPr algn="l" indent="0" marL="0">
+              <a:buNone/>
+            </a:pPr>
+            <a:r>
+              <a:rPr lang="en-US" sz="950" b="1" spc="130" kern="0" dirty="0">
                 <a:solidFill>
                   <a:srgbClr val="3F4E10"/>
                 </a:solidFill>
@@ -7780,7 +8009,7 @@
                 <a:ea typeface="Calibri" pitchFamily="34" charset="-122"/>
                 <a:cs typeface="Calibri" pitchFamily="34" charset="-120"/>
               </a:rPr>
-              <a:t>BASIS DATA</a:t>
+              <a:t>DATABASE</a:t>
             </a:r>
             <a:endParaRPr lang="en-US" sz="950" dirty="0"/>
           </a:p>
@@ -7807,7 +8036,7 @@
           <a:bodyPr wrap="square" lIns="0" tIns="0" rIns="0" bIns="0" rtlCol="0" anchor="t"/>
           <a:lstStyle/>
           <a:p>
-            <a:pPr marL="0" indent="0" algn="l">
+            <a:pPr algn="l" indent="0" marL="0">
               <a:lnSpc>
                 <a:spcPts val="1700"/>
               </a:lnSpc>
@@ -7822,7 +8051,7 @@
                 <a:ea typeface="Calibri" pitchFamily="34" charset="-122"/>
                 <a:cs typeface="Calibri" pitchFamily="34" charset="-120"/>
               </a:rPr>
-              <a:t>Berupa satu berkas. Tanpa MySQL, tanpa XAMPP.</a:t>
+              <a:t>Cukup satu file. Tidak perlu MySQL atau XAMPP.</a:t>
             </a:r>
             <a:endParaRPr lang="en-US" sz="1250" dirty="0"/>
           </a:p>
@@ -7871,7 +8100,7 @@
           <a:bodyPr wrap="square" lIns="0" tIns="0" rIns="0" bIns="0" rtlCol="0" anchor="t"/>
           <a:lstStyle/>
           <a:p>
-            <a:pPr marL="0" indent="0" algn="l">
+            <a:pPr algn="l" indent="0" marL="0">
               <a:buNone/>
             </a:pPr>
             <a:r>
@@ -7910,11 +8139,11 @@
           <a:bodyPr wrap="square" lIns="0" tIns="0" rIns="0" bIns="0" rtlCol="0" anchor="t"/>
           <a:lstStyle/>
           <a:p>
-            <a:pPr marL="0" indent="0" algn="l">
-              <a:buNone/>
-            </a:pPr>
-            <a:r>
-              <a:rPr lang="en-US" sz="950" b="1" kern="0" spc="130" dirty="0">
+            <a:pPr algn="l" indent="0" marL="0">
+              <a:buNone/>
+            </a:pPr>
+            <a:r>
+              <a:rPr lang="en-US" sz="950" b="1" spc="130" kern="0" dirty="0">
                 <a:solidFill>
                   <a:srgbClr val="BBD4E8"/>
                 </a:solidFill>
@@ -7922,7 +8151,7 @@
                 <a:ea typeface="Calibri" pitchFamily="34" charset="-122"/>
                 <a:cs typeface="Calibri" pitchFamily="34" charset="-120"/>
               </a:rPr>
-              <a:t>ANTARMUKA</a:t>
+              <a:t>TAMPILAN</a:t>
             </a:r>
             <a:endParaRPr lang="en-US" sz="950" dirty="0"/>
           </a:p>
@@ -7949,7 +8178,7 @@
           <a:bodyPr wrap="square" lIns="0" tIns="0" rIns="0" bIns="0" rtlCol="0" anchor="t"/>
           <a:lstStyle/>
           <a:p>
-            <a:pPr marL="0" indent="0" algn="l">
+            <a:pPr algn="l" indent="0" marL="0">
               <a:lnSpc>
                 <a:spcPts val="1700"/>
               </a:lnSpc>
@@ -7964,7 +8193,7 @@
                 <a:ea typeface="Calibri" pitchFamily="34" charset="-122"/>
                 <a:cs typeface="Calibri" pitchFamily="34" charset="-120"/>
               </a:rPr>
-              <a:t>Halaman berat dimuat terpisah agar pelapor tidak ikut mengunduhnya.</a:t>
+              <a:t>Halaman yang berat dipisah, jadi web tetap ringan dibuka.</a:t>
             </a:r>
             <a:endParaRPr lang="en-US" sz="1250" dirty="0"/>
           </a:p>
@@ -8013,7 +8242,7 @@
           <a:bodyPr wrap="square" lIns="0" tIns="0" rIns="0" bIns="0" rtlCol="0" anchor="t"/>
           <a:lstStyle/>
           <a:p>
-            <a:pPr marL="0" indent="0" algn="l">
+            <a:pPr algn="l" indent="0" marL="0">
               <a:buNone/>
             </a:pPr>
             <a:r>
@@ -8025,7 +8254,7 @@
                 <a:ea typeface="Calibri" pitchFamily="34" charset="-122"/>
                 <a:cs typeface="Calibri" pitchFamily="34" charset="-120"/>
               </a:rPr>
-              <a:t>Berkas JSON</a:t>
+              <a:t>File JSON</a:t>
             </a:r>
             <a:endParaRPr lang="en-US" sz="2100" dirty="0"/>
           </a:p>
@@ -8052,11 +8281,11 @@
           <a:bodyPr wrap="square" lIns="0" tIns="0" rIns="0" bIns="0" rtlCol="0" anchor="t"/>
           <a:lstStyle/>
           <a:p>
-            <a:pPr marL="0" indent="0" algn="l">
-              <a:buNone/>
-            </a:pPr>
-            <a:r>
-              <a:rPr lang="en-US" sz="950" b="1" kern="0" spc="130" dirty="0">
+            <a:pPr algn="l" indent="0" marL="0">
+              <a:buNone/>
+            </a:pPr>
+            <a:r>
+              <a:rPr lang="en-US" sz="950" b="1" spc="130" kern="0" dirty="0">
                 <a:solidFill>
                   <a:srgbClr val="F6C9CE"/>
                 </a:solidFill>
@@ -8064,7 +8293,7 @@
                 <a:ea typeface="Calibri" pitchFamily="34" charset="-122"/>
                 <a:cs typeface="Calibri" pitchFamily="34" charset="-120"/>
               </a:rPr>
-              <a:t>BASIS PENGETAHUAN</a:t>
+              <a:t>KUMPULAN SOP</a:t>
             </a:r>
             <a:endParaRPr lang="en-US" sz="950" dirty="0"/>
           </a:p>
@@ -8091,7 +8320,7 @@
           <a:bodyPr wrap="square" lIns="0" tIns="0" rIns="0" bIns="0" rtlCol="0" anchor="t"/>
           <a:lstStyle/>
           <a:p>
-            <a:pPr marL="0" indent="0" algn="l">
+            <a:pPr algn="l" indent="0" marL="0">
               <a:lnSpc>
                 <a:spcPts val="1700"/>
               </a:lnSpc>
@@ -8106,7 +8335,7 @@
                 <a:ea typeface="Calibri" pitchFamily="34" charset="-122"/>
                 <a:cs typeface="Calibri" pitchFamily="34" charset="-120"/>
               </a:rPr>
-              <a:t>SOP disunting lewat peramban, tanpa menyentuh kode.</a:t>
+              <a:t>SOP bisa diubah lewat browser, tanpa menyentuh kode.</a:t>
             </a:r>
             <a:endParaRPr lang="en-US" sz="1250" dirty="0"/>
           </a:p>
@@ -8157,7 +8386,7 @@
           <a:bodyPr wrap="square" lIns="0" tIns="0" rIns="0" bIns="0" rtlCol="0" anchor="t"/>
           <a:lstStyle/>
           <a:p>
-            <a:pPr marL="0" indent="0" algn="l">
+            <a:pPr algn="l" indent="0" marL="0">
               <a:buNone/>
             </a:pPr>
             <a:r>
@@ -8196,7 +8425,7 @@
           <a:bodyPr wrap="square" lIns="0" tIns="0" rIns="0" bIns="0" rtlCol="0" anchor="t"/>
           <a:lstStyle/>
           <a:p>
-            <a:pPr marL="0" indent="0" algn="l">
+            <a:pPr algn="l" indent="0" marL="0">
               <a:buNone/>
             </a:pPr>
             <a:r>
@@ -8208,7 +8437,7 @@
                 <a:ea typeface="Calibri" pitchFamily="34" charset="-122"/>
                 <a:cs typeface="Calibri" pitchFamily="34" charset="-120"/>
               </a:rPr>
-              <a:t>Seluruh sistem berjalan di jaringan kantor sendiri.</a:t>
+              <a:t>Semua berjalan di jaringan kantor sendiri.</a:t>
             </a:r>
             <a:endParaRPr lang="en-US" sz="1300" dirty="0"/>
           </a:p>
@@ -8235,7 +8464,7 @@
           <a:bodyPr wrap="square" lIns="0" tIns="0" rIns="0" bIns="0" rtlCol="0" anchor="t"/>
           <a:lstStyle/>
           <a:p>
-            <a:pPr marL="0" indent="0" algn="ctr">
+            <a:pPr algn="ctr" indent="0" marL="0">
               <a:buNone/>
             </a:pPr>
             <a:r>
@@ -8274,7 +8503,7 @@
           <a:bodyPr wrap="square" lIns="0" tIns="0" rIns="0" bIns="0" rtlCol="0" anchor="t"/>
           <a:lstStyle/>
           <a:p>
-            <a:pPr marL="0" indent="0" algn="ctr">
+            <a:pPr algn="ctr" indent="0" marL="0">
               <a:lnSpc>
                 <a:spcPts val="1400"/>
               </a:lnSpc>
@@ -8289,7 +8518,7 @@
                 <a:ea typeface="Calibri" pitchFamily="34" charset="-122"/>
                 <a:cs typeface="Calibri" pitchFamily="34" charset="-120"/>
               </a:rPr>
-              <a:t>pustaka luar</a:t>
+              <a:t>komponen tambahan</a:t>
             </a:r>
             <a:endParaRPr lang="en-US" sz="1100" dirty="0"/>
           </a:p>
@@ -8316,7 +8545,7 @@
           <a:bodyPr wrap="square" lIns="0" tIns="0" rIns="0" bIns="0" rtlCol="0" anchor="t"/>
           <a:lstStyle/>
           <a:p>
-            <a:pPr marL="0" indent="0" algn="ctr">
+            <a:pPr algn="ctr" indent="0" marL="0">
               <a:buNone/>
             </a:pPr>
             <a:r>
@@ -8355,7 +8584,7 @@
           <a:bodyPr wrap="square" lIns="0" tIns="0" rIns="0" bIns="0" rtlCol="0" anchor="t"/>
           <a:lstStyle/>
           <a:p>
-            <a:pPr marL="0" indent="0" algn="ctr">
+            <a:pPr algn="ctr" indent="0" marL="0">
               <a:lnSpc>
                 <a:spcPts val="1400"/>
               </a:lnSpc>
@@ -8397,7 +8626,7 @@
           <a:bodyPr wrap="square" lIns="0" tIns="0" rIns="0" bIns="0" rtlCol="0" anchor="t"/>
           <a:lstStyle/>
           <a:p>
-            <a:pPr marL="0" indent="0" algn="ctr">
+            <a:pPr algn="ctr" indent="0" marL="0">
               <a:buNone/>
             </a:pPr>
             <a:r>
@@ -8436,7 +8665,7 @@
           <a:bodyPr wrap="square" lIns="0" tIns="0" rIns="0" bIns="0" rtlCol="0" anchor="t"/>
           <a:lstStyle/>
           <a:p>
-            <a:pPr marL="0" indent="0" algn="ctr">
+            <a:pPr algn="ctr" indent="0" marL="0">
               <a:lnSpc>
                 <a:spcPts val="1400"/>
               </a:lnSpc>
@@ -8451,7 +8680,7 @@
                 <a:ea typeface="Calibri" pitchFamily="34" charset="-122"/>
                 <a:cs typeface="Calibri" pitchFamily="34" charset="-120"/>
               </a:rPr>
-              <a:t>berkas basis data</a:t>
+              <a:t>file database</a:t>
             </a:r>
             <a:endParaRPr lang="en-US" sz="1100" dirty="0"/>
           </a:p>
@@ -8471,7 +8700,7 @@
     <p:bg>
       <p:bgPr>
         <a:blipFill dpi="0" rotWithShape="1">
-          <a:blip r:embed="rId3">
+          <a:blip r:embed="rId1">
             <a:lum/>
           </a:blip>
           <a:srcRect/>
@@ -8539,11 +8768,11 @@
           <a:bodyPr wrap="square" lIns="0" tIns="0" rIns="0" bIns="0" rtlCol="0" anchor="t"/>
           <a:lstStyle/>
           <a:p>
-            <a:pPr marL="0" indent="0" algn="l">
-              <a:buNone/>
-            </a:pPr>
-            <a:r>
-              <a:rPr lang="en-US" sz="1150" b="1" kern="0" spc="180" dirty="0">
+            <a:pPr algn="l" indent="0" marL="0">
+              <a:buNone/>
+            </a:pPr>
+            <a:r>
+              <a:rPr lang="en-US" sz="1150" b="1" spc="180" kern="0" dirty="0">
                 <a:solidFill>
                   <a:srgbClr val="005694"/>
                 </a:solidFill>
@@ -8578,7 +8807,7 @@
           <a:bodyPr wrap="square" lIns="0" tIns="0" rIns="0" bIns="0" rtlCol="0" anchor="t"/>
           <a:lstStyle/>
           <a:p>
-            <a:pPr marL="0" indent="0" algn="l">
+            <a:pPr algn="l" indent="0" marL="0">
               <a:buNone/>
             </a:pPr>
             <a:r>
@@ -8639,7 +8868,7 @@
           <a:bodyPr wrap="square" lIns="0" tIns="0" rIns="0" bIns="0" rtlCol="0" anchor="t"/>
           <a:lstStyle/>
           <a:p>
-            <a:pPr marL="0" indent="0" algn="ctr">
+            <a:pPr algn="ctr" indent="0" marL="0">
               <a:buNone/>
             </a:pPr>
             <a:r>
@@ -8678,7 +8907,7 @@
           <a:bodyPr wrap="square" lIns="0" tIns="0" rIns="0" bIns="0" rtlCol="0" anchor="t"/>
           <a:lstStyle/>
           <a:p>
-            <a:pPr marL="0" indent="0" algn="ctr">
+            <a:pPr algn="ctr" indent="0" marL="0">
               <a:buNone/>
             </a:pPr>
             <a:r>
@@ -8717,7 +8946,7 @@
           <a:bodyPr wrap="square" lIns="0" tIns="0" rIns="0" bIns="0" rtlCol="0" anchor="t"/>
           <a:lstStyle/>
           <a:p>
-            <a:pPr marL="0" indent="0" algn="ctr">
+            <a:pPr algn="ctr" indent="0" marL="0">
               <a:lnSpc>
                 <a:spcPts val="1600"/>
               </a:lnSpc>
@@ -8781,7 +9010,7 @@
           <a:bodyPr wrap="square" lIns="0" tIns="0" rIns="0" bIns="0" rtlCol="0" anchor="t"/>
           <a:lstStyle/>
           <a:p>
-            <a:pPr marL="0" indent="0" algn="ctr">
+            <a:pPr algn="ctr" indent="0" marL="0">
               <a:buNone/>
             </a:pPr>
             <a:r>
@@ -8820,7 +9049,7 @@
           <a:bodyPr wrap="square" lIns="0" tIns="0" rIns="0" bIns="0" rtlCol="0" anchor="t"/>
           <a:lstStyle/>
           <a:p>
-            <a:pPr marL="0" indent="0" algn="ctr">
+            <a:pPr algn="ctr" indent="0" marL="0">
               <a:buNone/>
             </a:pPr>
             <a:r>
@@ -8859,7 +9088,7 @@
           <a:bodyPr wrap="square" lIns="0" tIns="0" rIns="0" bIns="0" rtlCol="0" anchor="t"/>
           <a:lstStyle/>
           <a:p>
-            <a:pPr marL="0" indent="0" algn="ctr">
+            <a:pPr algn="ctr" indent="0" marL="0">
               <a:lnSpc>
                 <a:spcPts val="1600"/>
               </a:lnSpc>
@@ -8923,7 +9152,7 @@
           <a:bodyPr wrap="square" lIns="0" tIns="0" rIns="0" bIns="0" rtlCol="0" anchor="t"/>
           <a:lstStyle/>
           <a:p>
-            <a:pPr marL="0" indent="0" algn="ctr">
+            <a:pPr algn="ctr" indent="0" marL="0">
               <a:buNone/>
             </a:pPr>
             <a:r>
@@ -8962,7 +9191,7 @@
           <a:bodyPr wrap="square" lIns="0" tIns="0" rIns="0" bIns="0" rtlCol="0" anchor="t"/>
           <a:lstStyle/>
           <a:p>
-            <a:pPr marL="0" indent="0" algn="ctr">
+            <a:pPr algn="ctr" indent="0" marL="0">
               <a:buNone/>
             </a:pPr>
             <a:r>
@@ -9001,7 +9230,7 @@
           <a:bodyPr wrap="square" lIns="0" tIns="0" rIns="0" bIns="0" rtlCol="0" anchor="t"/>
           <a:lstStyle/>
           <a:p>
-            <a:pPr marL="0" indent="0" algn="ctr">
+            <a:pPr algn="ctr" indent="0" marL="0">
               <a:lnSpc>
                 <a:spcPts val="1600"/>
               </a:lnSpc>
@@ -9065,11 +9294,11 @@
           <a:bodyPr wrap="square" lIns="0" tIns="0" rIns="0" bIns="0" rtlCol="0" anchor="t"/>
           <a:lstStyle/>
           <a:p>
-            <a:pPr marL="0" indent="0" algn="l">
-              <a:buNone/>
-            </a:pPr>
-            <a:r>
-              <a:rPr lang="en-US" sz="1150" b="1" kern="0" spc="150" dirty="0">
+            <a:pPr algn="l" indent="0" marL="0">
+              <a:buNone/>
+            </a:pPr>
+            <a:r>
+              <a:rPr lang="en-US" sz="1150" b="1" spc="150" kern="0" dirty="0">
                 <a:solidFill>
                   <a:srgbClr val="C41022"/>
                 </a:solidFill>
@@ -9128,7 +9357,7 @@
           <a:bodyPr wrap="square" lIns="0" tIns="0" rIns="0" bIns="0" rtlCol="0" anchor="t"/>
           <a:lstStyle/>
           <a:p>
-            <a:pPr marL="0" indent="0" algn="l">
+            <a:pPr algn="l" indent="0" marL="0">
               <a:buNone/>
             </a:pPr>
             <a:r>
@@ -9167,7 +9396,7 @@
           <a:bodyPr wrap="square" lIns="0" tIns="0" rIns="0" bIns="0" rtlCol="0" anchor="t"/>
           <a:lstStyle/>
           <a:p>
-            <a:pPr marL="0" indent="0" algn="l">
+            <a:pPr algn="l" indent="0" marL="0">
               <a:lnSpc>
                 <a:spcPts val="1600"/>
               </a:lnSpc>
@@ -9233,7 +9462,7 @@
           <a:bodyPr wrap="square" lIns="0" tIns="0" rIns="0" bIns="0" rtlCol="0" anchor="t"/>
           <a:lstStyle/>
           <a:p>
-            <a:pPr marL="0" indent="0" algn="l">
+            <a:pPr algn="l" indent="0" marL="0">
               <a:buNone/>
             </a:pPr>
             <a:r>
@@ -9272,7 +9501,7 @@
           <a:bodyPr wrap="square" lIns="0" tIns="0" rIns="0" bIns="0" rtlCol="0" anchor="t"/>
           <a:lstStyle/>
           <a:p>
-            <a:pPr marL="0" indent="0" algn="l">
+            <a:pPr algn="l" indent="0" marL="0">
               <a:lnSpc>
                 <a:spcPts val="1600"/>
               </a:lnSpc>
@@ -9307,7 +9536,7 @@
     <p:bg>
       <p:bgPr>
         <a:blipFill dpi="0" rotWithShape="1">
-          <a:blip r:embed="rId3">
+          <a:blip r:embed="rId1">
             <a:lum/>
           </a:blip>
           <a:srcRect/>
@@ -9401,7 +9630,7 @@
           <a:bodyPr wrap="square" lIns="0" tIns="0" rIns="0" bIns="0" rtlCol="0" anchor="t"/>
           <a:lstStyle/>
           <a:p>
-            <a:pPr marL="0" indent="0" algn="l">
+            <a:pPr algn="l" indent="0" marL="0">
               <a:buNone/>
             </a:pPr>
             <a:r>
@@ -9460,7 +9689,7 @@
           <a:bodyPr wrap="square" lIns="0" tIns="0" rIns="0" bIns="0" rtlCol="0" anchor="t"/>
           <a:lstStyle/>
           <a:p>
-            <a:pPr marL="0" indent="0" algn="l">
+            <a:pPr algn="l" indent="0" marL="0">
               <a:buNone/>
             </a:pPr>
             <a:r>
@@ -9499,7 +9728,7 @@
           <a:bodyPr wrap="square" lIns="0" tIns="0" rIns="0" bIns="0" rtlCol="0" anchor="t"/>
           <a:lstStyle/>
           <a:p>
-            <a:pPr marL="0" indent="0" algn="l">
+            <a:pPr algn="l" indent="0" marL="0">
               <a:lnSpc>
                 <a:spcPts val="2300"/>
               </a:lnSpc>
@@ -9534,7 +9763,7 @@
     <p:bg>
       <p:bgPr>
         <a:blipFill dpi="0" rotWithShape="1">
-          <a:blip r:embed="rId3">
+          <a:blip r:embed="rId1">
             <a:lum/>
           </a:blip>
           <a:srcRect/>
@@ -9633,14 +9862,14 @@
       </p:sp>
       <p:pic>
         <p:nvPicPr>
-          <p:cNvPr id="5" name="Image 0" descr="D:\KILAT\KILAT-Ketersediaan-Informasi-Layanan-ICT-Terpadu-main\dokumentasi\ppt\ilustrasi\5-demo.jpg"/>
+          <p:cNvPr id="5" name="Image 0" descr="D:\KILAT\KILAT-Ketersediaan-Informasi-Layanan-ICT-Terpadu-main\dokumentasi\ppt\ilustrasi\5-demo.jpg">    </p:cNvPr>
           <p:cNvPicPr>
             <a:picLocks noChangeAspect="1"/>
           </p:cNvPicPr>
           <p:nvPr/>
         </p:nvPicPr>
         <p:blipFill>
-          <a:blip r:embed="rId4"/>
+          <a:blip r:embed="rId2"/>
           <a:stretch>
             <a:fillRect/>
           </a:stretch>
@@ -9698,11 +9927,11 @@
           <a:bodyPr wrap="square" lIns="0" tIns="0" rIns="0" bIns="0" rtlCol="0" anchor="ctr"/>
           <a:lstStyle/>
           <a:p>
-            <a:pPr marL="0" indent="0" algn="ctr">
-              <a:buNone/>
-            </a:pPr>
-            <a:r>
-              <a:rPr lang="en-US" sz="1000" b="1" kern="0" spc="140" dirty="0">
+            <a:pPr algn="ctr" indent="0" marL="0">
+              <a:buNone/>
+            </a:pPr>
+            <a:r>
+              <a:rPr lang="en-US" sz="1000" b="1" spc="140" kern="0" dirty="0">
                 <a:solidFill>
                   <a:srgbClr val="002B47"/>
                 </a:solidFill>
@@ -9737,7 +9966,7 @@
           <a:bodyPr wrap="square" lIns="0" tIns="0" rIns="0" bIns="0" rtlCol="0" anchor="t"/>
           <a:lstStyle/>
           <a:p>
-            <a:pPr marL="0" indent="0" algn="l">
+            <a:pPr algn="l" indent="0" marL="0">
               <a:lnSpc>
                 <a:spcPts val="6000"/>
               </a:lnSpc>
@@ -9757,7 +9986,7 @@
             <a:endParaRPr lang="en-US" sz="5400" dirty="0"/>
           </a:p>
           <a:p>
-            <a:pPr marL="0" indent="0" algn="l">
+            <a:pPr algn="l" indent="0" marL="0">
               <a:lnSpc>
                 <a:spcPts val="6000"/>
               </a:lnSpc>
@@ -9819,7 +10048,7 @@
           <a:bodyPr wrap="square" lIns="0" tIns="0" rIns="0" bIns="0" rtlCol="0" anchor="t"/>
           <a:lstStyle/>
           <a:p>
-            <a:pPr marL="0" indent="0" algn="l">
+            <a:pPr algn="l" indent="0" marL="0">
               <a:lnSpc>
                 <a:spcPts val="2200"/>
               </a:lnSpc>
@@ -9907,7 +10136,7 @@
           <a:bodyPr wrap="square" lIns="0" tIns="0" rIns="0" bIns="0" rtlCol="0" anchor="t"/>
           <a:lstStyle/>
           <a:p>
-            <a:pPr marL="0" indent="0" algn="l">
+            <a:pPr algn="l" indent="0" marL="0">
               <a:buNone/>
             </a:pPr>
             <a:r>
@@ -9968,7 +10197,7 @@
           <a:bodyPr wrap="square" lIns="0" tIns="0" rIns="0" bIns="0" rtlCol="0" anchor="t"/>
           <a:lstStyle/>
           <a:p>
-            <a:pPr marL="0" indent="0" algn="l">
+            <a:pPr algn="l" indent="0" marL="0">
               <a:buNone/>
             </a:pPr>
             <a:r>
@@ -10029,7 +10258,7 @@
           <a:bodyPr wrap="square" lIns="0" tIns="0" rIns="0" bIns="0" rtlCol="0" anchor="t"/>
           <a:lstStyle/>
           <a:p>
-            <a:pPr marL="0" indent="0" algn="l">
+            <a:pPr algn="l" indent="0" marL="0">
               <a:buNone/>
             </a:pPr>
             <a:r>
@@ -10061,7 +10290,7 @@
     <p:bg>
       <p:bgPr>
         <a:blipFill dpi="0" rotWithShape="1">
-          <a:blip r:embed="rId3">
+          <a:blip r:embed="rId1">
             <a:lum/>
           </a:blip>
           <a:srcRect/>
@@ -10129,11 +10358,11 @@
           <a:bodyPr wrap="square" lIns="0" tIns="0" rIns="0" bIns="0" rtlCol="0" anchor="t"/>
           <a:lstStyle/>
           <a:p>
-            <a:pPr marL="0" indent="0" algn="l">
-              <a:buNone/>
-            </a:pPr>
-            <a:r>
-              <a:rPr lang="en-US" sz="1150" b="1" kern="0" spc="180" dirty="0">
+            <a:pPr algn="l" indent="0" marL="0">
+              <a:buNone/>
+            </a:pPr>
+            <a:r>
+              <a:rPr lang="en-US" sz="1150" b="1" spc="180" kern="0" dirty="0">
                 <a:solidFill>
                   <a:srgbClr val="5C6A0D"/>
                 </a:solidFill>
@@ -10168,7 +10397,7 @@
           <a:bodyPr wrap="square" lIns="0" tIns="0" rIns="0" bIns="0" rtlCol="0" anchor="t"/>
           <a:lstStyle/>
           <a:p>
-            <a:pPr marL="0" indent="0" algn="l">
+            <a:pPr algn="l" indent="0" marL="0">
               <a:buNone/>
             </a:pPr>
             <a:r>
@@ -10253,7 +10482,7 @@
           <a:bodyPr wrap="square" lIns="0" tIns="0" rIns="0" bIns="0" rtlCol="0" anchor="t"/>
           <a:lstStyle/>
           <a:p>
-            <a:pPr marL="0" indent="0" algn="l">
+            <a:pPr algn="l" indent="0" marL="0">
               <a:buNone/>
             </a:pPr>
             <a:r>
@@ -10292,7 +10521,7 @@
           <a:bodyPr wrap="square" lIns="0" tIns="0" rIns="0" bIns="0" rtlCol="0" anchor="t"/>
           <a:lstStyle/>
           <a:p>
-            <a:pPr marL="0" indent="0" algn="l">
+            <a:pPr algn="l" indent="0" marL="0">
               <a:lnSpc>
                 <a:spcPts val="1700"/>
               </a:lnSpc>
@@ -10380,7 +10609,7 @@
           <a:bodyPr wrap="square" lIns="0" tIns="0" rIns="0" bIns="0" rtlCol="0" anchor="t"/>
           <a:lstStyle/>
           <a:p>
-            <a:pPr marL="0" indent="0" algn="l">
+            <a:pPr algn="l" indent="0" marL="0">
               <a:buNone/>
             </a:pPr>
             <a:r>
@@ -10419,7 +10648,7 @@
           <a:bodyPr wrap="square" lIns="0" tIns="0" rIns="0" bIns="0" rtlCol="0" anchor="t"/>
           <a:lstStyle/>
           <a:p>
-            <a:pPr marL="0" indent="0" algn="l">
+            <a:pPr algn="l" indent="0" marL="0">
               <a:lnSpc>
                 <a:spcPts val="1700"/>
               </a:lnSpc>
@@ -10507,7 +10736,7 @@
           <a:bodyPr wrap="square" lIns="0" tIns="0" rIns="0" bIns="0" rtlCol="0" anchor="t"/>
           <a:lstStyle/>
           <a:p>
-            <a:pPr marL="0" indent="0" algn="l">
+            <a:pPr algn="l" indent="0" marL="0">
               <a:buNone/>
             </a:pPr>
             <a:r>
@@ -10546,7 +10775,7 @@
           <a:bodyPr wrap="square" lIns="0" tIns="0" rIns="0" bIns="0" rtlCol="0" anchor="t"/>
           <a:lstStyle/>
           <a:p>
-            <a:pPr marL="0" indent="0" algn="l">
+            <a:pPr algn="l" indent="0" marL="0">
               <a:lnSpc>
                 <a:spcPts val="1700"/>
               </a:lnSpc>
@@ -10634,7 +10863,7 @@
           <a:bodyPr wrap="square" lIns="0" tIns="0" rIns="0" bIns="0" rtlCol="0" anchor="t"/>
           <a:lstStyle/>
           <a:p>
-            <a:pPr marL="0" indent="0" algn="l">
+            <a:pPr algn="l" indent="0" marL="0">
               <a:buNone/>
             </a:pPr>
             <a:r>
@@ -10673,7 +10902,7 @@
           <a:bodyPr wrap="square" lIns="0" tIns="0" rIns="0" bIns="0" rtlCol="0" anchor="t"/>
           <a:lstStyle/>
           <a:p>
-            <a:pPr marL="0" indent="0" algn="l">
+            <a:pPr algn="l" indent="0" marL="0">
               <a:lnSpc>
                 <a:spcPts val="1700"/>
               </a:lnSpc>
@@ -10759,7 +10988,7 @@
           <a:bodyPr wrap="square" lIns="0" tIns="0" rIns="0" bIns="0" rtlCol="0" anchor="t"/>
           <a:lstStyle/>
           <a:p>
-            <a:pPr marL="0" indent="0" algn="l">
+            <a:pPr algn="l" indent="0" marL="0">
               <a:buNone/>
             </a:pPr>
             <a:r>
@@ -10798,7 +11027,7 @@
           <a:bodyPr wrap="square" lIns="0" tIns="0" rIns="0" bIns="0" rtlCol="0" anchor="t"/>
           <a:lstStyle/>
           <a:p>
-            <a:pPr marL="0" indent="0" algn="l">
+            <a:pPr algn="l" indent="0" marL="0">
               <a:lnSpc>
                 <a:spcPts val="1700"/>
               </a:lnSpc>
@@ -10833,7 +11062,7 @@
     <p:bg>
       <p:bgPr>
         <a:blipFill dpi="0" rotWithShape="1">
-          <a:blip r:embed="rId3">
+          <a:blip r:embed="rId1">
             <a:lum/>
           </a:blip>
           <a:srcRect/>
@@ -10949,11 +11178,11 @@
           <a:bodyPr wrap="square" lIns="0" tIns="0" rIns="0" bIns="0" rtlCol="0" anchor="ctr"/>
           <a:lstStyle/>
           <a:p>
-            <a:pPr marL="0" indent="0" algn="ctr">
-              <a:buNone/>
-            </a:pPr>
-            <a:r>
-              <a:rPr lang="en-US" sz="1050" b="1" kern="0" spc="150" dirty="0">
+            <a:pPr algn="ctr" indent="0" marL="0">
+              <a:buNone/>
+            </a:pPr>
+            <a:r>
+              <a:rPr lang="en-US" sz="1050" b="1" spc="150" kern="0" dirty="0">
                 <a:solidFill>
                   <a:srgbClr val="002B47"/>
                 </a:solidFill>
@@ -10988,7 +11217,7 @@
           <a:bodyPr wrap="square" lIns="0" tIns="0" rIns="0" bIns="0" rtlCol="0" anchor="t"/>
           <a:lstStyle/>
           <a:p>
-            <a:pPr marL="0" indent="0" algn="l">
+            <a:pPr algn="l" indent="0" marL="0">
               <a:lnSpc>
                 <a:spcPts val="4400"/>
               </a:lnSpc>
@@ -11008,7 +11237,7 @@
             <a:endParaRPr lang="en-US" sz="3300" dirty="0"/>
           </a:p>
           <a:p>
-            <a:pPr marL="0" indent="0" algn="l">
+            <a:pPr algn="l" indent="0" marL="0">
               <a:lnSpc>
                 <a:spcPts val="4400"/>
               </a:lnSpc>
@@ -11072,7 +11301,7 @@
           <a:bodyPr wrap="square" lIns="0" tIns="0" rIns="0" bIns="0" rtlCol="0" anchor="t"/>
           <a:lstStyle/>
           <a:p>
-            <a:pPr marL="0" indent="0" algn="l">
+            <a:pPr algn="l" indent="0" marL="0">
               <a:buNone/>
             </a:pPr>
             <a:r>
@@ -11111,7 +11340,7 @@
           <a:bodyPr wrap="square" lIns="0" tIns="0" rIns="0" bIns="0" rtlCol="0" anchor="t"/>
           <a:lstStyle/>
           <a:p>
-            <a:pPr marL="0" indent="0" algn="l">
+            <a:pPr algn="l" indent="0" marL="0">
               <a:lnSpc>
                 <a:spcPts val="1700"/>
               </a:lnSpc>
@@ -11175,7 +11404,7 @@
           <a:bodyPr wrap="square" lIns="0" tIns="0" rIns="0" bIns="0" rtlCol="0" anchor="t"/>
           <a:lstStyle/>
           <a:p>
-            <a:pPr marL="0" indent="0" algn="l">
+            <a:pPr algn="l" indent="0" marL="0">
               <a:buNone/>
             </a:pPr>
             <a:r>
@@ -11214,7 +11443,7 @@
           <a:bodyPr wrap="square" lIns="0" tIns="0" rIns="0" bIns="0" rtlCol="0" anchor="t"/>
           <a:lstStyle/>
           <a:p>
-            <a:pPr marL="0" indent="0" algn="l">
+            <a:pPr algn="l" indent="0" marL="0">
               <a:lnSpc>
                 <a:spcPts val="1700"/>
               </a:lnSpc>
@@ -11280,7 +11509,7 @@
           <a:bodyPr wrap="square" lIns="0" tIns="0" rIns="0" bIns="0" rtlCol="0" anchor="t"/>
           <a:lstStyle/>
           <a:p>
-            <a:pPr marL="0" indent="0" algn="l">
+            <a:pPr algn="l" indent="0" marL="0">
               <a:buNone/>
             </a:pPr>
             <a:r>
@@ -11319,7 +11548,7 @@
           <a:bodyPr wrap="square" lIns="0" tIns="0" rIns="0" bIns="0" rtlCol="0" anchor="t"/>
           <a:lstStyle/>
           <a:p>
-            <a:pPr marL="0" indent="0" algn="l">
+            <a:pPr algn="l" indent="0" marL="0">
               <a:lnSpc>
                 <a:spcPts val="1700"/>
               </a:lnSpc>
@@ -11361,7 +11590,7 @@
           <a:bodyPr wrap="square" lIns="0" tIns="0" rIns="0" bIns="0" rtlCol="0" anchor="t"/>
           <a:lstStyle/>
           <a:p>
-            <a:pPr marL="0" indent="0" algn="l">
+            <a:pPr algn="l" indent="0" marL="0">
               <a:buNone/>
             </a:pPr>
             <a:r>
@@ -11400,7 +11629,7 @@
           <a:bodyPr wrap="square" lIns="0" tIns="0" rIns="0" bIns="0" rtlCol="0" anchor="t"/>
           <a:lstStyle/>
           <a:p>
-            <a:pPr marL="0" indent="0" algn="l">
+            <a:pPr algn="l" indent="0" marL="0">
               <a:buNone/>
             </a:pPr>
             <a:r>
@@ -11432,7 +11661,7 @@
     <p:bg>
       <p:bgPr>
         <a:blipFill dpi="0" rotWithShape="1">
-          <a:blip r:embed="rId3">
+          <a:blip r:embed="rId1">
             <a:lum/>
           </a:blip>
           <a:srcRect/>
@@ -11500,11 +11729,11 @@
           <a:bodyPr wrap="square" lIns="0" tIns="0" rIns="0" bIns="0" rtlCol="0" anchor="t"/>
           <a:lstStyle/>
           <a:p>
-            <a:pPr marL="0" indent="0" algn="l">
-              <a:buNone/>
-            </a:pPr>
-            <a:r>
-              <a:rPr lang="en-US" sz="1150" b="1" kern="0" spc="180" dirty="0">
+            <a:pPr algn="l" indent="0" marL="0">
+              <a:buNone/>
+            </a:pPr>
+            <a:r>
+              <a:rPr lang="en-US" sz="1150" b="1" spc="180" kern="0" dirty="0">
                 <a:solidFill>
                   <a:srgbClr val="005694"/>
                 </a:solidFill>
@@ -11539,7 +11768,7 @@
           <a:bodyPr wrap="square" lIns="0" tIns="0" rIns="0" bIns="0" rtlCol="0" anchor="t"/>
           <a:lstStyle/>
           <a:p>
-            <a:pPr marL="0" indent="0" algn="l">
+            <a:pPr algn="l" indent="0" marL="0">
               <a:buNone/>
             </a:pPr>
             <a:r>
@@ -11556,7 +11785,7 @@
             <a:endParaRPr lang="en-US" sz="2800" dirty="0"/>
           </a:p>
           <a:p>
-            <a:pPr marL="0" indent="0" algn="l">
+            <a:pPr algn="l" indent="0" marL="0">
               <a:buNone/>
             </a:pPr>
             <a:r>
@@ -11600,14 +11829,14 @@
       </p:sp>
       <p:pic>
         <p:nvPicPr>
-          <p:cNvPr id="6" name="Image 0" descr="D:\KILAT\KILAT-Ketersediaan-Informasi-Layanan-ICT-Terpadu-main\dokumentasi\ppt\ilustrasi\2-masalah.jpg"/>
+          <p:cNvPr id="6" name="Image 0" descr="D:\KILAT\KILAT-Ketersediaan-Informasi-Layanan-ICT-Terpadu-main\dokumentasi\ppt\ilustrasi\2-masalah.jpg">    </p:cNvPr>
           <p:cNvPicPr>
             <a:picLocks noChangeAspect="1"/>
           </p:cNvPicPr>
           <p:nvPr/>
         </p:nvPicPr>
         <p:blipFill>
-          <a:blip r:embed="rId4"/>
+          <a:blip r:embed="rId2"/>
           <a:stretch>
             <a:fillRect/>
           </a:stretch>
@@ -11665,7 +11894,7 @@
           <a:bodyPr wrap="square" lIns="0" tIns="0" rIns="0" bIns="0" rtlCol="0" anchor="t"/>
           <a:lstStyle/>
           <a:p>
-            <a:pPr marL="0" indent="0" algn="l">
+            <a:pPr algn="l" indent="0" marL="0">
               <a:lnSpc>
                 <a:spcPts val="2100"/>
               </a:lnSpc>
@@ -11729,7 +11958,7 @@
           <a:bodyPr wrap="square" lIns="0" tIns="0" rIns="0" bIns="0" rtlCol="0" anchor="t"/>
           <a:lstStyle/>
           <a:p>
-            <a:pPr marL="0" indent="0" algn="l">
+            <a:pPr algn="l" indent="0" marL="0">
               <a:buNone/>
             </a:pPr>
             <a:r>
@@ -11790,7 +12019,7 @@
           <a:bodyPr wrap="square" lIns="0" tIns="0" rIns="0" bIns="0" rtlCol="0" anchor="t"/>
           <a:lstStyle/>
           <a:p>
-            <a:pPr marL="0" indent="0" algn="l">
+            <a:pPr algn="l" indent="0" marL="0">
               <a:buNone/>
             </a:pPr>
             <a:r>
@@ -11851,7 +12080,7 @@
           <a:bodyPr wrap="square" lIns="0" tIns="0" rIns="0" bIns="0" rtlCol="0" anchor="t"/>
           <a:lstStyle/>
           <a:p>
-            <a:pPr marL="0" indent="0" algn="l">
+            <a:pPr algn="l" indent="0" marL="0">
               <a:buNone/>
             </a:pPr>
             <a:r>
@@ -11912,7 +12141,7 @@
           <a:bodyPr wrap="square" lIns="0" tIns="0" rIns="0" bIns="0" rtlCol="0" anchor="t"/>
           <a:lstStyle/>
           <a:p>
-            <a:pPr marL="0" indent="0" algn="l">
+            <a:pPr algn="l" indent="0" marL="0">
               <a:buNone/>
             </a:pPr>
             <a:r>
@@ -11973,7 +12202,7 @@
           <a:bodyPr wrap="square" lIns="0" tIns="0" rIns="0" bIns="0" rtlCol="0" anchor="t"/>
           <a:lstStyle/>
           <a:p>
-            <a:pPr marL="0" indent="0" algn="l">
+            <a:pPr algn="l" indent="0" marL="0">
               <a:buNone/>
             </a:pPr>
             <a:r>
@@ -12034,7 +12263,7 @@
           <a:bodyPr wrap="square" lIns="0" tIns="0" rIns="0" bIns="0" rtlCol="0" anchor="t"/>
           <a:lstStyle/>
           <a:p>
-            <a:pPr marL="0" indent="0" algn="l">
+            <a:pPr algn="l" indent="0" marL="0">
               <a:lnSpc>
                 <a:spcPts val="2000"/>
               </a:lnSpc>
@@ -12069,7 +12298,7 @@
     <p:bg>
       <p:bgPr>
         <a:blipFill dpi="0" rotWithShape="1">
-          <a:blip r:embed="rId3">
+          <a:blip r:embed="rId1">
             <a:lum/>
           </a:blip>
           <a:srcRect/>
@@ -12137,11 +12366,11 @@
           <a:bodyPr wrap="square" lIns="0" tIns="0" rIns="0" bIns="0" rtlCol="0" anchor="t"/>
           <a:lstStyle/>
           <a:p>
-            <a:pPr marL="0" indent="0" algn="l">
-              <a:buNone/>
-            </a:pPr>
-            <a:r>
-              <a:rPr lang="en-US" sz="1150" b="1" kern="0" spc="180" dirty="0">
+            <a:pPr algn="l" indent="0" marL="0">
+              <a:buNone/>
+            </a:pPr>
+            <a:r>
+              <a:rPr lang="en-US" sz="1150" b="1" spc="180" kern="0" dirty="0">
                 <a:solidFill>
                   <a:srgbClr val="005694"/>
                 </a:solidFill>
@@ -12176,7 +12405,7 @@
           <a:bodyPr wrap="square" lIns="0" tIns="0" rIns="0" bIns="0" rtlCol="0" anchor="t"/>
           <a:lstStyle/>
           <a:p>
-            <a:pPr marL="0" indent="0" algn="l">
+            <a:pPr algn="l" indent="0" marL="0">
               <a:buNone/>
             </a:pPr>
             <a:r>
@@ -12259,7 +12488,7 @@
           <a:bodyPr wrap="square" lIns="0" tIns="0" rIns="0" bIns="0" rtlCol="0" anchor="ctr"/>
           <a:lstStyle/>
           <a:p>
-            <a:pPr marL="0" indent="0" algn="ctr">
+            <a:pPr algn="ctr" indent="0" marL="0">
               <a:buNone/>
             </a:pPr>
             <a:r>
@@ -12298,7 +12527,7 @@
           <a:bodyPr wrap="square" lIns="0" tIns="0" rIns="0" bIns="0" rtlCol="0" anchor="t"/>
           <a:lstStyle/>
           <a:p>
-            <a:pPr marL="0" indent="0" algn="l">
+            <a:pPr algn="l" indent="0" marL="0">
               <a:buNone/>
             </a:pPr>
             <a:r>
@@ -12337,7 +12566,7 @@
           <a:bodyPr wrap="square" lIns="0" tIns="0" rIns="0" bIns="0" rtlCol="0" anchor="t"/>
           <a:lstStyle/>
           <a:p>
-            <a:pPr marL="0" indent="0" algn="l">
+            <a:pPr algn="l" indent="0" marL="0">
               <a:lnSpc>
                 <a:spcPts val="1700"/>
               </a:lnSpc>
@@ -12423,7 +12652,7 @@
           <a:bodyPr wrap="square" lIns="0" tIns="0" rIns="0" bIns="0" rtlCol="0" anchor="ctr"/>
           <a:lstStyle/>
           <a:p>
-            <a:pPr marL="0" indent="0" algn="ctr">
+            <a:pPr algn="ctr" indent="0" marL="0">
               <a:buNone/>
             </a:pPr>
             <a:r>
@@ -12462,7 +12691,7 @@
           <a:bodyPr wrap="square" lIns="0" tIns="0" rIns="0" bIns="0" rtlCol="0" anchor="t"/>
           <a:lstStyle/>
           <a:p>
-            <a:pPr marL="0" indent="0" algn="l">
+            <a:pPr algn="l" indent="0" marL="0">
               <a:buNone/>
             </a:pPr>
             <a:r>
@@ -12501,7 +12730,7 @@
           <a:bodyPr wrap="square" lIns="0" tIns="0" rIns="0" bIns="0" rtlCol="0" anchor="t"/>
           <a:lstStyle/>
           <a:p>
-            <a:pPr marL="0" indent="0" algn="l">
+            <a:pPr algn="l" indent="0" marL="0">
               <a:lnSpc>
                 <a:spcPts val="1700"/>
               </a:lnSpc>
@@ -12587,7 +12816,7 @@
           <a:bodyPr wrap="square" lIns="0" tIns="0" rIns="0" bIns="0" rtlCol="0" anchor="ctr"/>
           <a:lstStyle/>
           <a:p>
-            <a:pPr marL="0" indent="0" algn="ctr">
+            <a:pPr algn="ctr" indent="0" marL="0">
               <a:buNone/>
             </a:pPr>
             <a:r>
@@ -12626,7 +12855,7 @@
           <a:bodyPr wrap="square" lIns="0" tIns="0" rIns="0" bIns="0" rtlCol="0" anchor="t"/>
           <a:lstStyle/>
           <a:p>
-            <a:pPr marL="0" indent="0" algn="l">
+            <a:pPr algn="l" indent="0" marL="0">
               <a:buNone/>
             </a:pPr>
             <a:r>
@@ -12665,7 +12894,7 @@
           <a:bodyPr wrap="square" lIns="0" tIns="0" rIns="0" bIns="0" rtlCol="0" anchor="t"/>
           <a:lstStyle/>
           <a:p>
-            <a:pPr marL="0" indent="0" algn="l">
+            <a:pPr algn="l" indent="0" marL="0">
               <a:lnSpc>
                 <a:spcPts val="1700"/>
               </a:lnSpc>
@@ -12751,7 +12980,7 @@
           <a:bodyPr wrap="square" lIns="0" tIns="0" rIns="0" bIns="0" rtlCol="0" anchor="ctr"/>
           <a:lstStyle/>
           <a:p>
-            <a:pPr marL="0" indent="0" algn="ctr">
+            <a:pPr algn="ctr" indent="0" marL="0">
               <a:buNone/>
             </a:pPr>
             <a:r>
@@ -12790,7 +13019,7 @@
           <a:bodyPr wrap="square" lIns="0" tIns="0" rIns="0" bIns="0" rtlCol="0" anchor="t"/>
           <a:lstStyle/>
           <a:p>
-            <a:pPr marL="0" indent="0" algn="l">
+            <a:pPr algn="l" indent="0" marL="0">
               <a:buNone/>
             </a:pPr>
             <a:r>
@@ -12829,7 +13058,7 @@
           <a:bodyPr wrap="square" lIns="0" tIns="0" rIns="0" bIns="0" rtlCol="0" anchor="t"/>
           <a:lstStyle/>
           <a:p>
-            <a:pPr marL="0" indent="0" algn="l">
+            <a:pPr algn="l" indent="0" marL="0">
               <a:lnSpc>
                 <a:spcPts val="1700"/>
               </a:lnSpc>
@@ -12915,7 +13144,7 @@
           <a:bodyPr wrap="square" lIns="0" tIns="0" rIns="0" bIns="0" rtlCol="0" anchor="ctr"/>
           <a:lstStyle/>
           <a:p>
-            <a:pPr marL="0" indent="0" algn="l">
+            <a:pPr algn="l" indent="0" marL="0">
               <a:buNone/>
             </a:pPr>
             <a:r>
@@ -12947,7 +13176,7 @@
     <p:bg>
       <p:bgPr>
         <a:blipFill dpi="0" rotWithShape="1">
-          <a:blip r:embed="rId3">
+          <a:blip r:embed="rId1">
             <a:lum/>
           </a:blip>
           <a:srcRect/>
@@ -13015,11 +13244,11 @@
           <a:bodyPr wrap="square" lIns="0" tIns="0" rIns="0" bIns="0" rtlCol="0" anchor="t"/>
           <a:lstStyle/>
           <a:p>
-            <a:pPr marL="0" indent="0" algn="l">
-              <a:buNone/>
-            </a:pPr>
-            <a:r>
-              <a:rPr lang="en-US" sz="1150" b="1" kern="0" spc="180" dirty="0">
+            <a:pPr algn="l" indent="0" marL="0">
+              <a:buNone/>
+            </a:pPr>
+            <a:r>
+              <a:rPr lang="en-US" sz="1150" b="1" spc="180" kern="0" dirty="0">
                 <a:solidFill>
                   <a:srgbClr val="005694"/>
                 </a:solidFill>
@@ -13054,7 +13283,7 @@
           <a:bodyPr wrap="square" lIns="0" tIns="0" rIns="0" bIns="0" rtlCol="0" anchor="t"/>
           <a:lstStyle/>
           <a:p>
-            <a:pPr marL="0" indent="0" algn="l">
+            <a:pPr algn="l" indent="0" marL="0">
               <a:buNone/>
             </a:pPr>
             <a:r>
@@ -13139,7 +13368,7 @@
           <a:bodyPr wrap="square" lIns="0" tIns="0" rIns="0" bIns="0" rtlCol="0" anchor="ctr"/>
           <a:lstStyle/>
           <a:p>
-            <a:pPr marL="0" indent="0" algn="ctr">
+            <a:pPr algn="ctr" indent="0" marL="0">
               <a:buNone/>
             </a:pPr>
             <a:r>
@@ -13178,7 +13407,7 @@
           <a:bodyPr wrap="square" lIns="0" tIns="0" rIns="0" bIns="0" rtlCol="0" anchor="t"/>
           <a:lstStyle/>
           <a:p>
-            <a:pPr marL="0" indent="0" algn="l">
+            <a:pPr algn="l" indent="0" marL="0">
               <a:buNone/>
             </a:pPr>
             <a:r>
@@ -13217,7 +13446,7 @@
           <a:bodyPr wrap="square" lIns="0" tIns="0" rIns="0" bIns="0" rtlCol="0" anchor="t"/>
           <a:lstStyle/>
           <a:p>
-            <a:pPr marL="0" indent="0" algn="l">
+            <a:pPr algn="l" indent="0" marL="0">
               <a:lnSpc>
                 <a:spcPts val="1800"/>
               </a:lnSpc>
@@ -13305,7 +13534,7 @@
           <a:bodyPr wrap="square" lIns="0" tIns="0" rIns="0" bIns="0" rtlCol="0" anchor="ctr"/>
           <a:lstStyle/>
           <a:p>
-            <a:pPr marL="0" indent="0" algn="ctr">
+            <a:pPr algn="ctr" indent="0" marL="0">
               <a:buNone/>
             </a:pPr>
             <a:r>
@@ -13344,7 +13573,7 @@
           <a:bodyPr wrap="square" lIns="0" tIns="0" rIns="0" bIns="0" rtlCol="0" anchor="t"/>
           <a:lstStyle/>
           <a:p>
-            <a:pPr marL="0" indent="0" algn="l">
+            <a:pPr algn="l" indent="0" marL="0">
               <a:buNone/>
             </a:pPr>
             <a:r>
@@ -13383,7 +13612,7 @@
           <a:bodyPr wrap="square" lIns="0" tIns="0" rIns="0" bIns="0" rtlCol="0" anchor="t"/>
           <a:lstStyle/>
           <a:p>
-            <a:pPr marL="0" indent="0" algn="l">
+            <a:pPr algn="l" indent="0" marL="0">
               <a:lnSpc>
                 <a:spcPts val="1800"/>
               </a:lnSpc>
@@ -13471,7 +13700,7 @@
           <a:bodyPr wrap="square" lIns="0" tIns="0" rIns="0" bIns="0" rtlCol="0" anchor="ctr"/>
           <a:lstStyle/>
           <a:p>
-            <a:pPr marL="0" indent="0" algn="ctr">
+            <a:pPr algn="ctr" indent="0" marL="0">
               <a:buNone/>
             </a:pPr>
             <a:r>
@@ -13510,7 +13739,7 @@
           <a:bodyPr wrap="square" lIns="0" tIns="0" rIns="0" bIns="0" rtlCol="0" anchor="t"/>
           <a:lstStyle/>
           <a:p>
-            <a:pPr marL="0" indent="0" algn="l">
+            <a:pPr algn="l" indent="0" marL="0">
               <a:buNone/>
             </a:pPr>
             <a:r>
@@ -13549,7 +13778,7 @@
           <a:bodyPr wrap="square" lIns="0" tIns="0" rIns="0" bIns="0" rtlCol="0" anchor="t"/>
           <a:lstStyle/>
           <a:p>
-            <a:pPr marL="0" indent="0" algn="l">
+            <a:pPr algn="l" indent="0" marL="0">
               <a:lnSpc>
                 <a:spcPts val="1800"/>
               </a:lnSpc>
@@ -13635,7 +13864,7 @@
           <a:bodyPr wrap="square" lIns="0" tIns="0" rIns="0" bIns="0" rtlCol="0" anchor="t"/>
           <a:lstStyle/>
           <a:p>
-            <a:pPr marL="0" indent="0" algn="l">
+            <a:pPr algn="l" indent="0" marL="0">
               <a:buNone/>
             </a:pPr>
             <a:r>
@@ -13674,7 +13903,7 @@
           <a:bodyPr wrap="square" lIns="0" tIns="0" rIns="0" bIns="0" rtlCol="0" anchor="t"/>
           <a:lstStyle/>
           <a:p>
-            <a:pPr marL="0" indent="0" algn="l">
+            <a:pPr algn="l" indent="0" marL="0">
               <a:lnSpc>
                 <a:spcPts val="2100"/>
               </a:lnSpc>
@@ -13716,7 +13945,7 @@
           <a:bodyPr wrap="square" lIns="0" tIns="0" rIns="0" bIns="0" rtlCol="0" anchor="t"/>
           <a:lstStyle/>
           <a:p>
-            <a:pPr marL="0" indent="0" algn="l">
+            <a:pPr algn="l" indent="0" marL="0">
               <a:lnSpc>
                 <a:spcPts val="1500"/>
               </a:lnSpc>
@@ -13751,7 +13980,7 @@
     <p:bg>
       <p:bgPr>
         <a:blipFill dpi="0" rotWithShape="1">
-          <a:blip r:embed="rId3">
+          <a:blip r:embed="rId1">
             <a:lum/>
           </a:blip>
           <a:srcRect/>
@@ -13845,7 +14074,7 @@
           <a:bodyPr wrap="square" lIns="0" tIns="0" rIns="0" bIns="0" rtlCol="0" anchor="t"/>
           <a:lstStyle/>
           <a:p>
-            <a:pPr marL="0" indent="0" algn="l">
+            <a:pPr algn="l" indent="0" marL="0">
               <a:buNone/>
             </a:pPr>
             <a:r>
@@ -13904,7 +14133,7 @@
           <a:bodyPr wrap="square" lIns="0" tIns="0" rIns="0" bIns="0" rtlCol="0" anchor="t"/>
           <a:lstStyle/>
           <a:p>
-            <a:pPr marL="0" indent="0" algn="l">
+            <a:pPr algn="l" indent="0" marL="0">
               <a:buNone/>
             </a:pPr>
             <a:r>
@@ -13943,7 +14172,7 @@
           <a:bodyPr wrap="square" lIns="0" tIns="0" rIns="0" bIns="0" rtlCol="0" anchor="t"/>
           <a:lstStyle/>
           <a:p>
-            <a:pPr marL="0" indent="0" algn="l">
+            <a:pPr algn="l" indent="0" marL="0">
               <a:lnSpc>
                 <a:spcPts val="2300"/>
               </a:lnSpc>
@@ -13978,7 +14207,7 @@
     <p:bg>
       <p:bgPr>
         <a:blipFill dpi="0" rotWithShape="1">
-          <a:blip r:embed="rId3">
+          <a:blip r:embed="rId1">
             <a:lum/>
           </a:blip>
           <a:srcRect/>
@@ -14046,11 +14275,11 @@
           <a:bodyPr wrap="square" lIns="0" tIns="0" rIns="0" bIns="0" rtlCol="0" anchor="t"/>
           <a:lstStyle/>
           <a:p>
-            <a:pPr marL="0" indent="0" algn="l">
-              <a:buNone/>
-            </a:pPr>
-            <a:r>
-              <a:rPr lang="en-US" sz="1150" b="1" kern="0" spc="180" dirty="0">
+            <a:pPr algn="l" indent="0" marL="0">
+              <a:buNone/>
+            </a:pPr>
+            <a:r>
+              <a:rPr lang="en-US" sz="1150" b="1" spc="180" kern="0" dirty="0">
                 <a:solidFill>
                   <a:srgbClr val="005694"/>
                 </a:solidFill>
@@ -14085,7 +14314,7 @@
           <a:bodyPr wrap="square" lIns="0" tIns="0" rIns="0" bIns="0" rtlCol="0" anchor="t"/>
           <a:lstStyle/>
           <a:p>
-            <a:pPr marL="0" indent="0" algn="l">
+            <a:pPr algn="l" indent="0" marL="0">
               <a:buNone/>
             </a:pPr>
             <a:r>
@@ -14129,14 +14358,14 @@
       </p:sp>
       <p:pic>
         <p:nvPicPr>
-          <p:cNvPr id="6" name="Image 0" descr="D:\KILAT\KILAT-Ketersediaan-Informasi-Layanan-ICT-Terpadu-main\dokumentasi\ppt\ilustrasi\1-hero.jpg"/>
+          <p:cNvPr id="6" name="Image 0" descr="D:\KILAT\KILAT-Ketersediaan-Informasi-Layanan-ICT-Terpadu-main\dokumentasi\ppt\ilustrasi\1-hero.jpg">    </p:cNvPr>
           <p:cNvPicPr>
             <a:picLocks noChangeAspect="1"/>
           </p:cNvPicPr>
           <p:nvPr/>
         </p:nvPicPr>
         <p:blipFill>
-          <a:blip r:embed="rId4"/>
+          <a:blip r:embed="rId2"/>
           <a:stretch>
             <a:fillRect/>
           </a:stretch>
@@ -14194,7 +14423,7 @@
           <a:bodyPr wrap="square" lIns="0" tIns="0" rIns="0" bIns="0" rtlCol="0" anchor="t"/>
           <a:lstStyle/>
           <a:p>
-            <a:pPr marL="0" indent="0" algn="l">
+            <a:pPr algn="l" indent="0" marL="0">
               <a:lnSpc>
                 <a:spcPts val="1800"/>
               </a:lnSpc>
@@ -14302,7 +14531,7 @@
           <a:bodyPr wrap="square" lIns="0" tIns="0" rIns="0" bIns="0" rtlCol="0" anchor="t"/>
           <a:lstStyle/>
           <a:p>
-            <a:pPr marL="0" indent="0" algn="l">
+            <a:pPr algn="l" indent="0" marL="0">
               <a:buNone/>
             </a:pPr>
             <a:r>
@@ -14341,7 +14570,7 @@
           <a:bodyPr wrap="square" lIns="0" tIns="0" rIns="0" bIns="0" rtlCol="0" anchor="t"/>
           <a:lstStyle/>
           <a:p>
-            <a:pPr marL="0" indent="0" algn="l">
+            <a:pPr algn="l" indent="0" marL="0">
               <a:lnSpc>
                 <a:spcPts val="1600"/>
               </a:lnSpc>
@@ -14356,7 +14585,7 @@
                 <a:ea typeface="Calibri" pitchFamily="34" charset="-122"/>
                 <a:cs typeface="Calibri" pitchFamily="34" charset="-120"/>
               </a:rPr>
-              <a:t>Cukup dibuka lewat peramban, tidak perlu memasang aplikasi apa pun.</a:t>
+              <a:t>Cukup dibuka lewat browser, tidak perlu memasang aplikasi apa pun.</a:t>
             </a:r>
             <a:endParaRPr lang="en-US" sz="1200" dirty="0"/>
           </a:p>
@@ -14449,7 +14678,7 @@
           <a:bodyPr wrap="square" lIns="0" tIns="0" rIns="0" bIns="0" rtlCol="0" anchor="t"/>
           <a:lstStyle/>
           <a:p>
-            <a:pPr marL="0" indent="0" algn="l">
+            <a:pPr algn="l" indent="0" marL="0">
               <a:buNone/>
             </a:pPr>
             <a:r>
@@ -14488,7 +14717,7 @@
           <a:bodyPr wrap="square" lIns="0" tIns="0" rIns="0" bIns="0" rtlCol="0" anchor="t"/>
           <a:lstStyle/>
           <a:p>
-            <a:pPr marL="0" indent="0" algn="l">
+            <a:pPr algn="l" indent="0" marL="0">
               <a:lnSpc>
                 <a:spcPts val="1600"/>
               </a:lnSpc>
@@ -14596,7 +14825,7 @@
           <a:bodyPr wrap="square" lIns="0" tIns="0" rIns="0" bIns="0" rtlCol="0" anchor="t"/>
           <a:lstStyle/>
           <a:p>
-            <a:pPr marL="0" indent="0" algn="l">
+            <a:pPr algn="l" indent="0" marL="0">
               <a:buNone/>
             </a:pPr>
             <a:r>
@@ -14635,7 +14864,7 @@
           <a:bodyPr wrap="square" lIns="0" tIns="0" rIns="0" bIns="0" rtlCol="0" anchor="t"/>
           <a:lstStyle/>
           <a:p>
-            <a:pPr marL="0" indent="0" algn="l">
+            <a:pPr algn="l" indent="0" marL="0">
               <a:lnSpc>
                 <a:spcPts val="1600"/>
               </a:lnSpc>
@@ -14743,7 +14972,7 @@
           <a:bodyPr wrap="square" lIns="0" tIns="0" rIns="0" bIns="0" rtlCol="0" anchor="t"/>
           <a:lstStyle/>
           <a:p>
-            <a:pPr marL="0" indent="0" algn="l">
+            <a:pPr algn="l" indent="0" marL="0">
               <a:buNone/>
             </a:pPr>
             <a:r>
@@ -14782,7 +15011,7 @@
           <a:bodyPr wrap="square" lIns="0" tIns="0" rIns="0" bIns="0" rtlCol="0" anchor="t"/>
           <a:lstStyle/>
           <a:p>
-            <a:pPr marL="0" indent="0" algn="l">
+            <a:pPr algn="l" indent="0" marL="0">
               <a:lnSpc>
                 <a:spcPts val="1600"/>
               </a:lnSpc>
@@ -14817,7 +15046,7 @@
     <p:bg>
       <p:bgPr>
         <a:blipFill dpi="0" rotWithShape="1">
-          <a:blip r:embed="rId3">
+          <a:blip r:embed="rId1">
             <a:lum/>
           </a:blip>
           <a:srcRect/>
@@ -14885,11 +15114,11 @@
           <a:bodyPr wrap="square" lIns="0" tIns="0" rIns="0" bIns="0" rtlCol="0" anchor="t"/>
           <a:lstStyle/>
           <a:p>
-            <a:pPr marL="0" indent="0" algn="l">
-              <a:buNone/>
-            </a:pPr>
-            <a:r>
-              <a:rPr lang="en-US" sz="1150" b="1" kern="0" spc="180" dirty="0">
+            <a:pPr algn="l" indent="0" marL="0">
+              <a:buNone/>
+            </a:pPr>
+            <a:r>
+              <a:rPr lang="en-US" sz="1150" b="1" spc="180" kern="0" dirty="0">
                 <a:solidFill>
                   <a:srgbClr val="5C6A0D"/>
                 </a:solidFill>
@@ -14924,7 +15153,7 @@
           <a:bodyPr wrap="square" lIns="0" tIns="0" rIns="0" bIns="0" rtlCol="0" anchor="t"/>
           <a:lstStyle/>
           <a:p>
-            <a:pPr marL="0" indent="0" algn="l">
+            <a:pPr algn="l" indent="0" marL="0">
               <a:buNone/>
             </a:pPr>
             <a:r>
@@ -14985,11 +15214,11 @@
           <a:bodyPr wrap="square" lIns="0" tIns="0" rIns="0" bIns="0" rtlCol="0" anchor="t"/>
           <a:lstStyle/>
           <a:p>
-            <a:pPr marL="0" indent="0" algn="l">
-              <a:buNone/>
-            </a:pPr>
-            <a:r>
-              <a:rPr lang="en-US" sz="1150" b="1" kern="0" spc="150" dirty="0">
+            <a:pPr algn="l" indent="0" marL="0">
+              <a:buNone/>
+            </a:pPr>
+            <a:r>
+              <a:rPr lang="en-US" sz="1150" b="1" spc="150" kern="0" dirty="0">
                 <a:solidFill>
                   <a:srgbClr val="5C6A0D"/>
                 </a:solidFill>
@@ -15046,7 +15275,7 @@
           <a:bodyPr wrap="square" lIns="0" tIns="0" rIns="0" bIns="0" rtlCol="0" anchor="t"/>
           <a:lstStyle/>
           <a:p>
-            <a:pPr marL="0" indent="0" algn="ctr">
+            <a:pPr algn="ctr" indent="0" marL="0">
               <a:buNone/>
             </a:pPr>
             <a:r>
@@ -15085,7 +15314,7 @@
           <a:bodyPr wrap="square" lIns="0" tIns="0" rIns="0" bIns="0" rtlCol="0" anchor="t"/>
           <a:lstStyle/>
           <a:p>
-            <a:pPr marL="0" indent="0" algn="ctr">
+            <a:pPr algn="ctr" indent="0" marL="0">
               <a:buNone/>
             </a:pPr>
             <a:r>
@@ -15146,7 +15375,7 @@
           <a:bodyPr wrap="square" lIns="0" tIns="0" rIns="0" bIns="0" rtlCol="0" anchor="t"/>
           <a:lstStyle/>
           <a:p>
-            <a:pPr marL="0" indent="0" algn="ctr">
+            <a:pPr algn="ctr" indent="0" marL="0">
               <a:buNone/>
             </a:pPr>
             <a:r>
@@ -15185,7 +15414,7 @@
           <a:bodyPr wrap="square" lIns="0" tIns="0" rIns="0" bIns="0" rtlCol="0" anchor="t"/>
           <a:lstStyle/>
           <a:p>
-            <a:pPr marL="0" indent="0" algn="ctr">
+            <a:pPr algn="ctr" indent="0" marL="0">
               <a:buNone/>
             </a:pPr>
             <a:r>
@@ -15248,7 +15477,7 @@
           <a:bodyPr wrap="square" lIns="0" tIns="0" rIns="0" bIns="0" rtlCol="0" anchor="t"/>
           <a:lstStyle/>
           <a:p>
-            <a:pPr marL="0" indent="0" algn="l">
+            <a:pPr algn="l" indent="0" marL="0">
               <a:lnSpc>
                 <a:spcPts val="1700"/>
               </a:lnSpc>
@@ -15312,11 +15541,11 @@
           <a:bodyPr wrap="square" lIns="0" tIns="0" rIns="0" bIns="0" rtlCol="0" anchor="t"/>
           <a:lstStyle/>
           <a:p>
-            <a:pPr marL="0" indent="0" algn="l">
-              <a:buNone/>
-            </a:pPr>
-            <a:r>
-              <a:rPr lang="en-US" sz="1150" b="1" kern="0" spc="150" dirty="0">
+            <a:pPr algn="l" indent="0" marL="0">
+              <a:buNone/>
+            </a:pPr>
+            <a:r>
+              <a:rPr lang="en-US" sz="1150" b="1" spc="150" kern="0" dirty="0">
                 <a:solidFill>
                   <a:srgbClr val="005694"/>
                 </a:solidFill>
@@ -15373,7 +15602,7 @@
           <a:bodyPr wrap="square" lIns="0" tIns="0" rIns="0" bIns="0" rtlCol="0" anchor="ctr"/>
           <a:lstStyle/>
           <a:p>
-            <a:pPr marL="0" indent="0" algn="ctr">
+            <a:pPr algn="ctr" indent="0" marL="0">
               <a:buNone/>
             </a:pPr>
             <a:r>
@@ -15434,7 +15663,7 @@
           <a:bodyPr wrap="square" lIns="0" tIns="0" rIns="0" bIns="0" rtlCol="0" anchor="ctr"/>
           <a:lstStyle/>
           <a:p>
-            <a:pPr marL="0" indent="0" algn="ctr">
+            <a:pPr algn="ctr" indent="0" marL="0">
               <a:buNone/>
             </a:pPr>
             <a:r>
@@ -15495,7 +15724,7 @@
           <a:bodyPr wrap="square" lIns="0" tIns="0" rIns="0" bIns="0" rtlCol="0" anchor="ctr"/>
           <a:lstStyle/>
           <a:p>
-            <a:pPr marL="0" indent="0" algn="ctr">
+            <a:pPr algn="ctr" indent="0" marL="0">
               <a:buNone/>
             </a:pPr>
             <a:r>
@@ -15556,7 +15785,7 @@
           <a:bodyPr wrap="square" lIns="0" tIns="0" rIns="0" bIns="0" rtlCol="0" anchor="ctr"/>
           <a:lstStyle/>
           <a:p>
-            <a:pPr marL="0" indent="0" algn="ctr">
+            <a:pPr algn="ctr" indent="0" marL="0">
               <a:buNone/>
             </a:pPr>
             <a:r>
@@ -15617,7 +15846,7 @@
           <a:bodyPr wrap="square" lIns="0" tIns="0" rIns="0" bIns="0" rtlCol="0" anchor="ctr"/>
           <a:lstStyle/>
           <a:p>
-            <a:pPr marL="0" indent="0" algn="ctr">
+            <a:pPr algn="ctr" indent="0" marL="0">
               <a:buNone/>
             </a:pPr>
             <a:r>
@@ -15678,7 +15907,7 @@
           <a:bodyPr wrap="square" lIns="0" tIns="0" rIns="0" bIns="0" rtlCol="0" anchor="ctr"/>
           <a:lstStyle/>
           <a:p>
-            <a:pPr marL="0" indent="0" algn="ctr">
+            <a:pPr algn="ctr" indent="0" marL="0">
               <a:buNone/>
             </a:pPr>
             <a:r>
@@ -15741,7 +15970,7 @@
           <a:bodyPr wrap="square" lIns="0" tIns="0" rIns="0" bIns="0" rtlCol="0" anchor="t"/>
           <a:lstStyle/>
           <a:p>
-            <a:pPr marL="0" indent="0" algn="l">
+            <a:pPr algn="l" indent="0" marL="0">
               <a:lnSpc>
                 <a:spcPts val="1700"/>
               </a:lnSpc>
@@ -15827,7 +16056,7 @@
           <a:bodyPr wrap="square" lIns="0" tIns="0" rIns="0" bIns="0" rtlCol="0" anchor="ctr"/>
           <a:lstStyle/>
           <a:p>
-            <a:pPr marL="0" indent="0" algn="l">
+            <a:pPr algn="l" indent="0" marL="0">
               <a:lnSpc>
                 <a:spcPts val="1900"/>
               </a:lnSpc>
@@ -15862,7 +16091,7 @@
     <p:bg>
       <p:bgPr>
         <a:blipFill dpi="0" rotWithShape="1">
-          <a:blip r:embed="rId3">
+          <a:blip r:embed="rId1">
             <a:lum/>
           </a:blip>
           <a:srcRect/>
@@ -15930,11 +16159,11 @@
           <a:bodyPr wrap="square" lIns="0" tIns="0" rIns="0" bIns="0" rtlCol="0" anchor="t"/>
           <a:lstStyle/>
           <a:p>
-            <a:pPr marL="0" indent="0" algn="l">
-              <a:buNone/>
-            </a:pPr>
-            <a:r>
-              <a:rPr lang="en-US" sz="1150" b="1" kern="0" spc="180" dirty="0">
+            <a:pPr algn="l" indent="0" marL="0">
+              <a:buNone/>
+            </a:pPr>
+            <a:r>
+              <a:rPr lang="en-US" sz="1150" b="1" spc="180" kern="0" dirty="0">
                 <a:solidFill>
                   <a:srgbClr val="005694"/>
                 </a:solidFill>
@@ -15969,7 +16198,7 @@
           <a:bodyPr wrap="square" lIns="0" tIns="0" rIns="0" bIns="0" rtlCol="0" anchor="t"/>
           <a:lstStyle/>
           <a:p>
-            <a:pPr marL="0" indent="0" algn="l">
+            <a:pPr algn="l" indent="0" marL="0">
               <a:buNone/>
             </a:pPr>
             <a:r>
@@ -16013,14 +16242,14 @@
       </p:sp>
       <p:pic>
         <p:nvPicPr>
-          <p:cNvPr id="6" name="Image 0" descr="D:\KILAT\KILAT-Ketersediaan-Informasi-Layanan-ICT-Terpadu-main\dokumentasi\diagram\gambar-4-17-perbandingan-alur.png"/>
+          <p:cNvPr id="6" name="Image 0" descr="D:\KILAT\KILAT-Ketersediaan-Informasi-Layanan-ICT-Terpadu-main\dokumentasi\diagram\gambar-4-17-perbandingan-alur.png">    </p:cNvPr>
           <p:cNvPicPr>
             <a:picLocks noChangeAspect="1"/>
           </p:cNvPicPr>
           <p:nvPr/>
         </p:nvPicPr>
         <p:blipFill>
-          <a:blip r:embed="rId4"/>
+          <a:blip r:embed="rId2"/>
           <a:stretch>
             <a:fillRect/>
           </a:stretch>
@@ -16336,299 +16565,4 @@
     </a:ext>
   </a:extLst>
 </a:theme>
-</file>
-
-<file path=ppt/theme/theme2.xml><?xml version="1.0" encoding="utf-8"?>
-<a:theme xmlns:a="http://schemas.openxmlformats.org/drawingml/2006/main" name="Office Theme">
-  <a:themeElements>
-    <a:clrScheme name="Office">
-      <a:dk1>
-        <a:sysClr val="windowText" lastClr="000000"/>
-      </a:dk1>
-      <a:lt1>
-        <a:sysClr val="window" lastClr="FFFFFF"/>
-      </a:lt1>
-      <a:dk2>
-        <a:srgbClr val="44546A"/>
-      </a:dk2>
-      <a:lt2>
-        <a:srgbClr val="E7E6E6"/>
-      </a:lt2>
-      <a:accent1>
-        <a:srgbClr val="4472C4"/>
-      </a:accent1>
-      <a:accent2>
-        <a:srgbClr val="ED7D31"/>
-      </a:accent2>
-      <a:accent3>
-        <a:srgbClr val="A5A5A5"/>
-      </a:accent3>
-      <a:accent4>
-        <a:srgbClr val="FFC000"/>
-      </a:accent4>
-      <a:accent5>
-        <a:srgbClr val="5B9BD5"/>
-      </a:accent5>
-      <a:accent6>
-        <a:srgbClr val="70AD47"/>
-      </a:accent6>
-      <a:hlink>
-        <a:srgbClr val="0563C1"/>
-      </a:hlink>
-      <a:folHlink>
-        <a:srgbClr val="954F72"/>
-      </a:folHlink>
-    </a:clrScheme>
-    <a:fontScheme name="Office">
-      <a:majorFont>
-        <a:latin typeface="Calibri Light" panose="020F0302020204030204"/>
-        <a:ea typeface=""/>
-        <a:cs typeface=""/>
-        <a:font script="Jpan" typeface="游ゴシック Light"/>
-        <a:font script="Hang" typeface="맑은 고딕"/>
-        <a:font script="Hans" typeface="等线 Light"/>
-        <a:font script="Hant" typeface="新細明體"/>
-        <a:font script="Arab" typeface="Times New Roman"/>
-        <a:font script="Hebr" typeface="Times New Roman"/>
-        <a:font script="Thai" typeface="Angsana New"/>
-        <a:font script="Ethi" typeface="Nyala"/>
-        <a:font script="Beng" typeface="Vrinda"/>
-        <a:font script="Gujr" typeface="Shruti"/>
-        <a:font script="Khmr" typeface="MoolBoran"/>
-        <a:font script="Knda" typeface="Tunga"/>
-        <a:font script="Guru" typeface="Raavi"/>
-        <a:font script="Cans" typeface="Euphemia"/>
-        <a:font script="Cher" typeface="Plantagenet Cherokee"/>
-        <a:font script="Yiii" typeface="Microsoft Yi Baiti"/>
-        <a:font script="Tibt" typeface="Microsoft Himalaya"/>
-        <a:font script="Thaa" typeface="MV Boli"/>
-        <a:font script="Deva" typeface="Mangal"/>
-        <a:font script="Telu" typeface="Gautami"/>
-        <a:font script="Taml" typeface="Latha"/>
-        <a:font script="Syrc" typeface="Estrangelo Edessa"/>
-        <a:font script="Orya" typeface="Kalinga"/>
-        <a:font script="Mlym" typeface="Kartika"/>
-        <a:font script="Laoo" typeface="DokChampa"/>
-        <a:font script="Sinh" typeface="Iskoola Pota"/>
-        <a:font script="Mong" typeface="Mongolian Baiti"/>
-        <a:font script="Viet" typeface="Times New Roman"/>
-        <a:font script="Uigh" typeface="Microsoft Uighur"/>
-        <a:font script="Geor" typeface="Sylfaen"/>
-        <a:font script="Armn" typeface="Arial"/>
-        <a:font script="Bugi" typeface="Leelawadee UI"/>
-        <a:font script="Bopo" typeface="Microsoft JhengHei"/>
-        <a:font script="Java" typeface="Javanese Text"/>
-        <a:font script="Lisu" typeface="Segoe UI"/>
-        <a:font script="Mymr" typeface="Myanmar Text"/>
-        <a:font script="Nkoo" typeface="Ebrima"/>
-        <a:font script="Olck" typeface="Nirmala UI"/>
-        <a:font script="Osma" typeface="Ebrima"/>
-        <a:font script="Phag" typeface="Phagspa"/>
-        <a:font script="Syrn" typeface="Estrangelo Edessa"/>
-        <a:font script="Syrj" typeface="Estrangelo Edessa"/>
-        <a:font script="Syre" typeface="Estrangelo Edessa"/>
-        <a:font script="Sora" typeface="Nirmala UI"/>
-        <a:font script="Tale" typeface="Microsoft Tai Le"/>
-        <a:font script="Talu" typeface="Microsoft New Tai Lue"/>
-        <a:font script="Tfng" typeface="Ebrima"/>
-      </a:majorFont>
-      <a:minorFont>
-        <a:latin typeface="Calibri" panose="020F0502020204030204"/>
-        <a:ea typeface=""/>
-        <a:cs typeface=""/>
-        <a:font script="Jpan" typeface="游ゴシック"/>
-        <a:font script="Hang" typeface="맑은 고딕"/>
-        <a:font script="Hans" typeface="等线"/>
-        <a:font script="Hant" typeface="新細明體"/>
-        <a:font script="Arab" typeface="Arial"/>
-        <a:font script="Hebr" typeface="Arial"/>
-        <a:font script="Thai" typeface="Cordia New"/>
-        <a:font script="Ethi" typeface="Nyala"/>
-        <a:font script="Beng" typeface="Vrinda"/>
-        <a:font script="Gujr" typeface="Shruti"/>
-        <a:font script="Khmr" typeface="DaunPenh"/>
-        <a:font script="Knda" typeface="Tunga"/>
-        <a:font script="Guru" typeface="Raavi"/>
-        <a:font script="Cans" typeface="Euphemia"/>
-        <a:font script="Cher" typeface="Plantagenet Cherokee"/>
-        <a:font script="Yiii" typeface="Microsoft Yi Baiti"/>
-        <a:font script="Tibt" typeface="Microsoft Himalaya"/>
-        <a:font script="Thaa" typeface="MV Boli"/>
-        <a:font script="Deva" typeface="Mangal"/>
-        <a:font script="Telu" typeface="Gautami"/>
-        <a:font script="Taml" typeface="Latha"/>
-        <a:font script="Syrc" typeface="Estrangelo Edessa"/>
-        <a:font script="Orya" typeface="Kalinga"/>
-        <a:font script="Mlym" typeface="Kartika"/>
-        <a:font script="Laoo" typeface="DokChampa"/>
-        <a:font script="Sinh" typeface="Iskoola Pota"/>
-        <a:font script="Mong" typeface="Mongolian Baiti"/>
-        <a:font script="Viet" typeface="Arial"/>
-        <a:font script="Uigh" typeface="Microsoft Uighur"/>
-        <a:font script="Geor" typeface="Sylfaen"/>
-        <a:font script="Armn" typeface="Arial"/>
-        <a:font script="Bugi" typeface="Leelawadee UI"/>
-        <a:font script="Bopo" typeface="Microsoft JhengHei"/>
-        <a:font script="Java" typeface="Javanese Text"/>
-        <a:font script="Lisu" typeface="Segoe UI"/>
-        <a:font script="Mymr" typeface="Myanmar Text"/>
-        <a:font script="Nkoo" typeface="Ebrima"/>
-        <a:font script="Olck" typeface="Nirmala UI"/>
-        <a:font script="Osma" typeface="Ebrima"/>
-        <a:font script="Phag" typeface="Phagspa"/>
-        <a:font script="Syrn" typeface="Estrangelo Edessa"/>
-        <a:font script="Syrj" typeface="Estrangelo Edessa"/>
-        <a:font script="Syre" typeface="Estrangelo Edessa"/>
-        <a:font script="Sora" typeface="Nirmala UI"/>
-        <a:font script="Tale" typeface="Microsoft Tai Le"/>
-        <a:font script="Talu" typeface="Microsoft New Tai Lue"/>
-        <a:font script="Tfng" typeface="Ebrima"/>
-      </a:minorFont>
-    </a:fontScheme>
-    <a:fmtScheme name="Office">
-      <a:fillStyleLst>
-        <a:solidFill>
-          <a:schemeClr val="phClr"/>
-        </a:solidFill>
-        <a:gradFill rotWithShape="1">
-          <a:gsLst>
-            <a:gs pos="0">
-              <a:schemeClr val="phClr">
-                <a:lumMod val="110000"/>
-                <a:satMod val="105000"/>
-                <a:tint val="67000"/>
-              </a:schemeClr>
-            </a:gs>
-            <a:gs pos="50000">
-              <a:schemeClr val="phClr">
-                <a:lumMod val="105000"/>
-                <a:satMod val="103000"/>
-                <a:tint val="73000"/>
-              </a:schemeClr>
-            </a:gs>
-            <a:gs pos="100000">
-              <a:schemeClr val="phClr">
-                <a:lumMod val="105000"/>
-                <a:satMod val="109000"/>
-                <a:tint val="81000"/>
-              </a:schemeClr>
-            </a:gs>
-          </a:gsLst>
-          <a:lin ang="5400000" scaled="0"/>
-        </a:gradFill>
-        <a:gradFill rotWithShape="1">
-          <a:gsLst>
-            <a:gs pos="0">
-              <a:schemeClr val="phClr">
-                <a:satMod val="103000"/>
-                <a:lumMod val="102000"/>
-                <a:tint val="94000"/>
-              </a:schemeClr>
-            </a:gs>
-            <a:gs pos="50000">
-              <a:schemeClr val="phClr">
-                <a:satMod val="110000"/>
-                <a:lumMod val="100000"/>
-                <a:shade val="100000"/>
-              </a:schemeClr>
-            </a:gs>
-            <a:gs pos="100000">
-              <a:schemeClr val="phClr">
-                <a:lumMod val="99000"/>
-                <a:satMod val="120000"/>
-                <a:shade val="78000"/>
-              </a:schemeClr>
-            </a:gs>
-          </a:gsLst>
-          <a:lin ang="5400000" scaled="0"/>
-        </a:gradFill>
-      </a:fillStyleLst>
-      <a:lnStyleLst>
-        <a:ln w="6350" cap="flat" cmpd="sng" algn="ctr">
-          <a:solidFill>
-            <a:schemeClr val="phClr"/>
-          </a:solidFill>
-          <a:prstDash val="solid"/>
-          <a:miter lim="800000"/>
-        </a:ln>
-        <a:ln w="12700" cap="flat" cmpd="sng" algn="ctr">
-          <a:solidFill>
-            <a:schemeClr val="phClr"/>
-          </a:solidFill>
-          <a:prstDash val="solid"/>
-          <a:miter lim="800000"/>
-        </a:ln>
-        <a:ln w="19050" cap="flat" cmpd="sng" algn="ctr">
-          <a:solidFill>
-            <a:schemeClr val="phClr"/>
-          </a:solidFill>
-          <a:prstDash val="solid"/>
-          <a:miter lim="800000"/>
-        </a:ln>
-      </a:lnStyleLst>
-      <a:effectStyleLst>
-        <a:effectStyle>
-          <a:effectLst/>
-        </a:effectStyle>
-        <a:effectStyle>
-          <a:effectLst/>
-        </a:effectStyle>
-        <a:effectStyle>
-          <a:effectLst>
-            <a:outerShdw blurRad="57150" dist="19050" dir="5400000" algn="ctr" rotWithShape="0">
-              <a:srgbClr val="000000">
-                <a:alpha val="63000"/>
-              </a:srgbClr>
-            </a:outerShdw>
-          </a:effectLst>
-        </a:effectStyle>
-      </a:effectStyleLst>
-      <a:bgFillStyleLst>
-        <a:solidFill>
-          <a:schemeClr val="phClr"/>
-        </a:solidFill>
-        <a:solidFill>
-          <a:schemeClr val="phClr">
-            <a:tint val="95000"/>
-            <a:satMod val="170000"/>
-          </a:schemeClr>
-        </a:solidFill>
-        <a:gradFill rotWithShape="1">
-          <a:gsLst>
-            <a:gs pos="0">
-              <a:schemeClr val="phClr">
-                <a:tint val="93000"/>
-                <a:satMod val="150000"/>
-                <a:shade val="98000"/>
-                <a:lumMod val="102000"/>
-              </a:schemeClr>
-            </a:gs>
-            <a:gs pos="50000">
-              <a:schemeClr val="phClr">
-                <a:tint val="98000"/>
-                <a:satMod val="130000"/>
-                <a:shade val="90000"/>
-                <a:lumMod val="103000"/>
-              </a:schemeClr>
-            </a:gs>
-            <a:gs pos="100000">
-              <a:schemeClr val="phClr">
-                <a:shade val="63000"/>
-                <a:satMod val="120000"/>
-              </a:schemeClr>
-            </a:gs>
-          </a:gsLst>
-          <a:lin ang="5400000" scaled="0"/>
-        </a:gradFill>
-      </a:bgFillStyleLst>
-    </a:fmtScheme>
-  </a:themeElements>
-  <a:objectDefaults/>
-  <a:extraClrSchemeLst/>
-  <a:extLst>
-    <a:ext uri="{05A4C25C-085E-4340-85A3-A5531E510DB2}">
-      <thm15:themeFamily xmlns:thm15="http://schemas.microsoft.com/office/thememl/2012/main" name="Office Theme" id="{62F939B6-93AF-4DB8-9C6B-D6C7DFDC589F}" vid="{4A3C46E8-61CC-4603-A589-7422A47A8E4A}"/>
-    </a:ext>
-  </a:extLst>
-</a:theme>
 </file>
</xml_diff>